<commit_message>
Update RISCV-MCU.pptx with revised content and enhancements
</commit_message>
<xml_diff>
--- a/Intro_PPT/RISCV-MCU.pptx
+++ b/Intro_PPT/RISCV-MCU.pptx
@@ -2784,7 +2784,7 @@
     </p:spTree>
     <p:extLst>
       <p:ext uri="{BB962C8B-B14F-4D97-AF65-F5344CB8AC3E}">
-        <p14:creationId xmlns:p14="http://schemas.microsoft.com/office/powerpoint/2010/main" val="3732878225"/>
+        <p14:creationId xmlns:p14="http://schemas.microsoft.com/office/powerpoint/2010/main" val="3746417443"/>
       </p:ext>
     </p:extLst>
   </p:cSld>
@@ -14897,6 +14897,36 @@
           <a:chExt cx="0" cy="0"/>
         </a:xfrm>
       </p:grpSpPr>
+      <p:pic>
+        <p:nvPicPr>
+          <p:cNvPr id="10" name="圖片 9">
+            <a:extLst>
+              <a:ext uri="{FF2B5EF4-FFF2-40B4-BE49-F238E27FC236}">
+                <a16:creationId xmlns:a16="http://schemas.microsoft.com/office/drawing/2014/main" id="{4CDC7642-BBA5-DB9C-286B-2338647CF970}"/>
+              </a:ext>
+            </a:extLst>
+          </p:cNvPr>
+          <p:cNvPicPr>
+            <a:picLocks noChangeAspect="1"/>
+          </p:cNvPicPr>
+          <p:nvPr/>
+        </p:nvPicPr>
+        <p:blipFill>
+          <a:blip r:embed="rId2"/>
+          <a:stretch>
+            <a:fillRect/>
+          </a:stretch>
+        </p:blipFill>
+        <p:spPr>
+          <a:xfrm>
+            <a:off x="7301031" y="1388187"/>
+            <a:ext cx="4890969" cy="4496974"/>
+          </a:xfrm>
+          <a:prstGeom prst="rect">
+            <a:avLst/>
+          </a:prstGeom>
+        </p:spPr>
+      </p:pic>
       <p:sp>
         <p:nvSpPr>
           <p:cNvPr id="2" name="標題 1">
@@ -14950,20 +14980,25 @@
             <p:ph idx="1"/>
           </p:nvPr>
         </p:nvSpPr>
-        <p:spPr/>
+        <p:spPr>
+          <a:xfrm>
+            <a:off x="334965" y="1482725"/>
+            <a:ext cx="11254061" cy="5113338"/>
+          </a:xfrm>
+        </p:spPr>
         <p:txBody>
           <a:bodyPr/>
           <a:lstStyle/>
           <a:p>
             <a:r>
-              <a:rPr lang="en-US" dirty="0"/>
+              <a:rPr lang="en-US" sz="2400" dirty="0"/>
               <a:t>XSDB (Xilinx System Debugger)</a:t>
             </a:r>
           </a:p>
           <a:p>
             <a:pPr lvl="1"/>
             <a:r>
-              <a:rPr lang="en-US" dirty="0">
+              <a:rPr lang="en-US" sz="2000" dirty="0">
                 <a:solidFill>
                   <a:srgbClr val="FF0000"/>
                 </a:solidFill>
@@ -14974,37 +15009,37 @@
           <a:p>
             <a:pPr lvl="1"/>
             <a:r>
-              <a:rPr lang="en-US" dirty="0"/>
+              <a:rPr lang="en-US" sz="2000" dirty="0"/>
               <a:t>Connects to </a:t>
             </a:r>
             <a:r>
-              <a:rPr lang="en-US" dirty="0" err="1"/>
+              <a:rPr lang="en-US" sz="2000" dirty="0" err="1"/>
               <a:t>MicroBlaze</a:t>
             </a:r>
             <a:r>
-              <a:rPr lang="en-US" dirty="0"/>
+              <a:rPr lang="en-US" sz="2000" dirty="0"/>
               <a:t> via MDM (</a:t>
             </a:r>
             <a:r>
-              <a:rPr lang="en-US" dirty="0" err="1"/>
+              <a:rPr lang="en-US" sz="2000" dirty="0" err="1"/>
               <a:t>MicroBlaze</a:t>
             </a:r>
             <a:r>
-              <a:rPr lang="en-US" dirty="0"/>
+              <a:rPr lang="en-US" sz="2000" dirty="0"/>
               <a:t> Debug Module)</a:t>
             </a:r>
           </a:p>
           <a:p>
             <a:pPr lvl="1"/>
             <a:r>
-              <a:rPr lang="en-US" dirty="0"/>
+              <a:rPr lang="en-US" sz="2000" dirty="0"/>
               <a:t>Capabilities: </a:t>
             </a:r>
           </a:p>
           <a:p>
             <a:pPr lvl="2"/>
             <a:r>
-              <a:rPr lang="en-US" dirty="0">
+              <a:rPr lang="en-US" sz="1800" dirty="0">
                 <a:solidFill>
                   <a:srgbClr val="FF0000"/>
                 </a:solidFill>
@@ -15012,7 +15047,7 @@
               <a:t>Download ELF directly to BRAM/SRAM/</a:t>
             </a:r>
             <a:r>
-              <a:rPr lang="en-US" altLang="zh-TW" dirty="0">
+              <a:rPr lang="en-US" altLang="zh-TW" sz="1800" dirty="0">
                 <a:solidFill>
                   <a:srgbClr val="FF0000"/>
                 </a:solidFill>
@@ -15020,7 +15055,7 @@
               <a:t>Flash</a:t>
             </a:r>
             <a:r>
-              <a:rPr lang="en-US" dirty="0">
+              <a:rPr lang="en-US" sz="1800" dirty="0">
                 <a:solidFill>
                   <a:srgbClr val="FF0000"/>
                 </a:solidFill>
@@ -15031,28 +15066,28 @@
           <a:p>
             <a:pPr lvl="2"/>
             <a:r>
-              <a:rPr lang="en-US" dirty="0"/>
+              <a:rPr lang="en-US" sz="1800" dirty="0"/>
               <a:t>Halt, step, and resume CPU execution</a:t>
             </a:r>
           </a:p>
           <a:p>
             <a:pPr lvl="2"/>
             <a:r>
-              <a:rPr lang="en-US" dirty="0"/>
+              <a:rPr lang="en-US" sz="1800" dirty="0"/>
               <a:t>Read/write memory and registers in real time</a:t>
             </a:r>
           </a:p>
           <a:p>
             <a:pPr lvl="2"/>
             <a:r>
-              <a:rPr lang="en-US" dirty="0"/>
+              <a:rPr lang="en-US" sz="1800" dirty="0"/>
               <a:t>Enables rapid code-test-fix cycles during development</a:t>
             </a:r>
           </a:p>
           <a:p>
             <a:pPr lvl="2"/>
             <a:r>
-              <a:rPr lang="en-US" dirty="0"/>
+              <a:rPr lang="en-US" sz="1800" dirty="0"/>
               <a:t>No bootloader required </a:t>
             </a:r>
           </a:p>

</xml_diff>

<commit_message>
Update presentation and architecture diagram with additional details on QSPI Flash memory
</commit_message>
<xml_diff>
--- a/Intro_PPT/RISCV-MCU.pptx
+++ b/Intro_PPT/RISCV-MCU.pptx
@@ -5,10 +5,10 @@
     <p:sldMasterId id="2147483660" r:id="rId1"/>
   </p:sldMasterIdLst>
   <p:notesMasterIdLst>
-    <p:notesMasterId r:id="rId35"/>
+    <p:notesMasterId r:id="rId37"/>
   </p:notesMasterIdLst>
   <p:handoutMasterIdLst>
-    <p:handoutMasterId r:id="rId36"/>
+    <p:handoutMasterId r:id="rId38"/>
   </p:handoutMasterIdLst>
   <p:sldIdLst>
     <p:sldId id="353" r:id="rId2"/>
@@ -25,25 +25,27 @@
     <p:sldId id="262" r:id="rId13"/>
     <p:sldId id="357" r:id="rId14"/>
     <p:sldId id="360" r:id="rId15"/>
-    <p:sldId id="271" r:id="rId16"/>
-    <p:sldId id="377" r:id="rId17"/>
-    <p:sldId id="378" r:id="rId18"/>
-    <p:sldId id="376" r:id="rId19"/>
-    <p:sldId id="362" r:id="rId20"/>
-    <p:sldId id="363" r:id="rId21"/>
-    <p:sldId id="302" r:id="rId22"/>
-    <p:sldId id="364" r:id="rId23"/>
-    <p:sldId id="263" r:id="rId24"/>
-    <p:sldId id="365" r:id="rId25"/>
-    <p:sldId id="272" r:id="rId26"/>
-    <p:sldId id="289" r:id="rId27"/>
-    <p:sldId id="366" r:id="rId28"/>
-    <p:sldId id="367" r:id="rId29"/>
-    <p:sldId id="368" r:id="rId30"/>
-    <p:sldId id="369" r:id="rId31"/>
-    <p:sldId id="370" r:id="rId32"/>
-    <p:sldId id="264" r:id="rId33"/>
-    <p:sldId id="374" r:id="rId34"/>
+    <p:sldId id="381" r:id="rId16"/>
+    <p:sldId id="271" r:id="rId17"/>
+    <p:sldId id="377" r:id="rId18"/>
+    <p:sldId id="378" r:id="rId19"/>
+    <p:sldId id="376" r:id="rId20"/>
+    <p:sldId id="362" r:id="rId21"/>
+    <p:sldId id="363" r:id="rId22"/>
+    <p:sldId id="302" r:id="rId23"/>
+    <p:sldId id="364" r:id="rId24"/>
+    <p:sldId id="263" r:id="rId25"/>
+    <p:sldId id="365" r:id="rId26"/>
+    <p:sldId id="272" r:id="rId27"/>
+    <p:sldId id="289" r:id="rId28"/>
+    <p:sldId id="366" r:id="rId29"/>
+    <p:sldId id="367" r:id="rId30"/>
+    <p:sldId id="368" r:id="rId31"/>
+    <p:sldId id="369" r:id="rId32"/>
+    <p:sldId id="370" r:id="rId33"/>
+    <p:sldId id="264" r:id="rId34"/>
+    <p:sldId id="382" r:id="rId35"/>
+    <p:sldId id="374" r:id="rId36"/>
   </p:sldIdLst>
   <p:sldSz cx="12192000" cy="6858000"/>
   <p:notesSz cx="6797675" cy="9926638"/>
@@ -232,7 +234,7 @@
           <a:p>
             <a:fld id="{FB399F11-57D9-4294-A5FE-64EE127CA968}" type="datetimeFigureOut">
               <a:rPr lang="zh-TW" altLang="en-US" smtClean="0"/>
-              <a:t>2026/4/14</a:t>
+              <a:t>2026/4/15</a:t>
             </a:fld>
             <a:endParaRPr lang="zh-TW" altLang="en-US"/>
           </a:p>
@@ -398,7 +400,7 @@
           <a:p>
             <a:fld id="{62527D1B-DA63-41BA-9798-D609BF505076}" type="datetimeFigureOut">
               <a:rPr lang="zh-TW" altLang="en-US" smtClean="0"/>
-              <a:t>2026/4/14</a:t>
+              <a:t>2026/4/15</a:t>
             </a:fld>
             <a:endParaRPr lang="zh-TW" altLang="en-US"/>
           </a:p>
@@ -2173,7 +2175,7 @@
                   <a:srgbClr val="000000"/>
                 </a:solidFill>
               </a:rPr>
-              <a:t>2026/4/14</a:t>
+              <a:t>2026/4/15</a:t>
             </a:fld>
             <a:endParaRPr lang="zh-TW" altLang="en-US">
               <a:solidFill>
@@ -2346,7 +2348,7 @@
           <a:p>
             <a:fld id="{AC144876-D6B9-4FEE-BE3A-F4CD2EEB4379}" type="datetime1">
               <a:rPr lang="zh-TW" altLang="en-US" smtClean="0"/>
-              <a:t>2026/4/14</a:t>
+              <a:t>2026/4/15</a:t>
             </a:fld>
             <a:endParaRPr lang="zh-TW" altLang="en-US"/>
           </a:p>
@@ -2543,7 +2545,7 @@
           <a:p>
             <a:fld id="{1BA259BF-DE45-49FA-A477-968460ED4E03}" type="datetime1">
               <a:rPr lang="zh-TW" altLang="en-US" smtClean="0"/>
-              <a:t>2026/4/14</a:t>
+              <a:t>2026/4/15</a:t>
             </a:fld>
             <a:endParaRPr lang="zh-TW" altLang="en-US"/>
           </a:p>
@@ -2918,7 +2920,7 @@
           <a:p>
             <a:fld id="{06BD1EBB-F0A8-4B9C-9D4E-C17A8A5A2449}" type="datetime1">
               <a:rPr lang="zh-TW" altLang="en-US" smtClean="0"/>
-              <a:t>2026/4/14</a:t>
+              <a:t>2026/4/15</a:t>
             </a:fld>
             <a:endParaRPr lang="zh-TW" altLang="en-US"/>
           </a:p>
@@ -3136,7 +3138,7 @@
           <a:p>
             <a:fld id="{F492EEED-A9B7-42BC-A1F2-60B82C4FBAE6}" type="datetime1">
               <a:rPr lang="zh-TW" altLang="en-US" smtClean="0"/>
-              <a:t>2026/4/14</a:t>
+              <a:t>2026/4/15</a:t>
             </a:fld>
             <a:endParaRPr lang="zh-TW" altLang="en-US"/>
           </a:p>
@@ -3440,7 +3442,7 @@
           <a:p>
             <a:fld id="{86B513EE-F750-4072-AF1B-A20318CC106B}" type="datetime1">
               <a:rPr lang="zh-TW" altLang="en-US" smtClean="0"/>
-              <a:t>2026/4/14</a:t>
+              <a:t>2026/4/15</a:t>
             </a:fld>
             <a:endParaRPr lang="zh-TW" altLang="en-US"/>
           </a:p>
@@ -3887,7 +3889,7 @@
           <a:p>
             <a:fld id="{0103FB19-3342-4E79-ADCE-9DB99AA56126}" type="datetime1">
               <a:rPr lang="zh-TW" altLang="en-US" smtClean="0"/>
-              <a:t>2026/4/14</a:t>
+              <a:t>2026/4/15</a:t>
             </a:fld>
             <a:endParaRPr lang="zh-TW" altLang="en-US"/>
           </a:p>
@@ -4023,7 +4025,7 @@
           <a:p>
             <a:fld id="{53B2D14A-D3C7-490B-A8E1-96FA496324EF}" type="datetime1">
               <a:rPr lang="zh-TW" altLang="en-US" smtClean="0"/>
-              <a:t>2026/4/14</a:t>
+              <a:t>2026/4/15</a:t>
             </a:fld>
             <a:endParaRPr lang="zh-TW" altLang="en-US"/>
           </a:p>
@@ -4137,7 +4139,7 @@
           <a:p>
             <a:fld id="{57E911DC-77C9-4ADC-B07E-272A68DBFA14}" type="datetime1">
               <a:rPr lang="zh-TW" altLang="en-US" smtClean="0"/>
-              <a:t>2026/4/14</a:t>
+              <a:t>2026/4/15</a:t>
             </a:fld>
             <a:endParaRPr lang="zh-TW" altLang="en-US"/>
           </a:p>
@@ -4431,7 +4433,7 @@
           <a:p>
             <a:fld id="{B95B21CB-16DD-4E49-B691-7AAC81A3EA8C}" type="datetime1">
               <a:rPr lang="zh-TW" altLang="en-US" smtClean="0"/>
-              <a:t>2026/4/14</a:t>
+              <a:t>2026/4/15</a:t>
             </a:fld>
             <a:endParaRPr lang="zh-TW" altLang="en-US"/>
           </a:p>
@@ -4706,7 +4708,7 @@
           <a:p>
             <a:fld id="{CEF4F6D1-4FC1-4DE7-B4BC-17972AA62A4A}" type="datetime1">
               <a:rPr lang="zh-TW" altLang="en-US" smtClean="0"/>
-              <a:t>2026/4/14</a:t>
+              <a:t>2026/4/15</a:t>
             </a:fld>
             <a:endParaRPr lang="zh-TW" altLang="en-US"/>
           </a:p>
@@ -5048,7 +5050,7 @@
           <a:p>
             <a:fld id="{6B6E154F-CDA9-41F4-98F3-1230ED3328AC}" type="datetime1">
               <a:rPr lang="zh-TW" altLang="en-US" smtClean="0"/>
-              <a:t>2026/4/14</a:t>
+              <a:t>2026/4/15</a:t>
             </a:fld>
             <a:endParaRPr lang="zh-TW" altLang="en-US"/>
           </a:p>
@@ -6682,15 +6684,7 @@
             </a:pPr>
             <a:r>
               <a:rPr lang="en-US" sz="2400" dirty="0"/>
-              <a:t>Processor: </a:t>
-            </a:r>
-            <a:r>
-              <a:rPr lang="en-US" sz="2400" dirty="0" err="1"/>
-              <a:t>MicroBlaze</a:t>
-            </a:r>
-            <a:r>
-              <a:rPr lang="en-US" sz="2400" dirty="0"/>
-              <a:t> RISC-V, </a:t>
+              <a:t>Processor: MicroBlaze RISC-V, </a:t>
             </a:r>
             <a:r>
               <a:rPr lang="en-US" sz="2400" dirty="0">
@@ -6938,7 +6932,7 @@
                 <a:latin typeface="Times New Roman" panose="02020603050405020304" pitchFamily="18" charset="0"/>
                 <a:cs typeface="Times New Roman" panose="02020603050405020304" pitchFamily="18" charset="0"/>
               </a:rPr>
-              <a:t>GPIO / Interrupt System / </a:t>
+              <a:t>MDM / GPIO / Interrupt System / </a:t>
             </a:r>
             <a:r>
               <a:rPr lang="zh-TW" altLang="en-US" sz="2400" dirty="0">
@@ -7108,6 +7102,234 @@
   <p:cSld>
     <p:spTree>
       <p:nvGrpSpPr>
+        <p:cNvPr id="1" name=""/>
+        <p:cNvGrpSpPr/>
+        <p:nvPr/>
+      </p:nvGrpSpPr>
+      <p:grpSpPr>
+        <a:xfrm>
+          <a:off x="0" y="0"/>
+          <a:ext cx="0" cy="0"/>
+          <a:chOff x="0" y="0"/>
+          <a:chExt cx="0" cy="0"/>
+        </a:xfrm>
+      </p:grpSpPr>
+      <p:sp>
+        <p:nvSpPr>
+          <p:cNvPr id="2" name="標題 1">
+            <a:extLst>
+              <a:ext uri="{FF2B5EF4-FFF2-40B4-BE49-F238E27FC236}">
+                <a16:creationId xmlns:a16="http://schemas.microsoft.com/office/drawing/2014/main" id="{397664A7-ADAC-EC8D-1CE9-BD4E4447EE02}"/>
+              </a:ext>
+            </a:extLst>
+          </p:cNvPr>
+          <p:cNvSpPr>
+            <a:spLocks noGrp="1"/>
+          </p:cNvSpPr>
+          <p:nvPr>
+            <p:ph type="title"/>
+          </p:nvPr>
+        </p:nvSpPr>
+        <p:spPr/>
+        <p:txBody>
+          <a:bodyPr/>
+          <a:lstStyle/>
+          <a:p>
+            <a:r>
+              <a:rPr lang="en-US" spc="-1" dirty="0">
+                <a:ea typeface="Calibri"/>
+              </a:rPr>
+              <a:t>MDM (MicroBlaze Debug Module)</a:t>
+            </a:r>
+            <a:endParaRPr lang="en-US" dirty="0"/>
+          </a:p>
+        </p:txBody>
+      </p:sp>
+      <p:sp>
+        <p:nvSpPr>
+          <p:cNvPr id="3" name="內容版面配置區 2">
+            <a:extLst>
+              <a:ext uri="{FF2B5EF4-FFF2-40B4-BE49-F238E27FC236}">
+                <a16:creationId xmlns:a16="http://schemas.microsoft.com/office/drawing/2014/main" id="{149F3C96-C183-8CE2-CFE6-8D70C932263D}"/>
+              </a:ext>
+            </a:extLst>
+          </p:cNvPr>
+          <p:cNvSpPr>
+            <a:spLocks noGrp="1"/>
+          </p:cNvSpPr>
+          <p:nvPr>
+            <p:ph idx="1"/>
+          </p:nvPr>
+        </p:nvSpPr>
+        <p:spPr/>
+        <p:txBody>
+          <a:bodyPr/>
+          <a:lstStyle/>
+          <a:p>
+            <a:r>
+              <a:rPr lang="en-US" sz="2400" b="1" dirty="0"/>
+              <a:t>MDM (MicroBlaze Debug Module)</a:t>
+            </a:r>
+            <a:endParaRPr lang="en-US" sz="2400" dirty="0"/>
+          </a:p>
+          <a:p>
+            <a:pPr lvl="1"/>
+            <a:r>
+              <a:rPr lang="en-US" sz="2000" dirty="0"/>
+              <a:t>Hardware debug bridge: JTAG ↔ MicroBlaze RISC-V core</a:t>
+            </a:r>
+          </a:p>
+          <a:p>
+            <a:pPr lvl="1"/>
+            <a:r>
+              <a:rPr lang="en-US" sz="2000" dirty="0"/>
+              <a:t>Connected to MicroBlaze via </a:t>
+            </a:r>
+            <a:r>
+              <a:rPr lang="en-US" sz="2000" b="1" dirty="0"/>
+              <a:t>DEBUG port</a:t>
+            </a:r>
+          </a:p>
+          <a:p>
+            <a:r>
+              <a:rPr lang="en-US" sz="2400" dirty="0"/>
+              <a:t>Debug Memory Access (RISC-V Debug Spec</a:t>
+            </a:r>
+            <a:r>
+              <a:rPr lang="zh-TW" altLang="en-US" sz="2400" dirty="0"/>
+              <a:t> </a:t>
+            </a:r>
+            <a:r>
+              <a:rPr lang="en-US" altLang="zh-TW" sz="2400" dirty="0"/>
+              <a:t>0</a:t>
+            </a:r>
+            <a:r>
+              <a:rPr lang="en-US" sz="2400" dirty="0"/>
+              <a:t>.13.2):</a:t>
+            </a:r>
+          </a:p>
+          <a:p>
+            <a:pPr lvl="1"/>
+            <a:r>
+              <a:rPr lang="en-US" sz="2000" b="1" dirty="0"/>
+              <a:t>Abstract Access</a:t>
+            </a:r>
+            <a:r>
+              <a:rPr lang="en-US" sz="2000" dirty="0"/>
+              <a:t> — debugger issues memory read/write commands directly through the Debug Module, without CPU involvement </a:t>
+            </a:r>
+          </a:p>
+          <a:p>
+            <a:pPr lvl="1"/>
+            <a:r>
+              <a:rPr lang="en-US" sz="2000" b="1" dirty="0"/>
+              <a:t>Program Buffer </a:t>
+            </a:r>
+            <a:r>
+              <a:rPr lang="en-US" sz="2000" dirty="0"/>
+              <a:t>— Debug Module halts the CPU, then injects load/store instructions for the CPU to execute on its own bus interface</a:t>
+            </a:r>
+          </a:p>
+          <a:p>
+            <a:r>
+              <a:rPr lang="en-US" sz="2400" dirty="0"/>
+              <a:t>Data Path:</a:t>
+            </a:r>
+          </a:p>
+          <a:p>
+            <a:pPr lvl="1"/>
+            <a:r>
+              <a:rPr lang="en-US" sz="2000" dirty="0"/>
+              <a:t>PC → USB → JTAG → </a:t>
+            </a:r>
+            <a:r>
+              <a:rPr lang="en-US" sz="2000" b="1" dirty="0"/>
+              <a:t>MDM</a:t>
+            </a:r>
+            <a:r>
+              <a:rPr lang="en-US" sz="2000" dirty="0"/>
+              <a:t> → </a:t>
+            </a:r>
+            <a:r>
+              <a:rPr lang="en-US" altLang="zh-TW" sz="2000" dirty="0"/>
+              <a:t>CPU</a:t>
+            </a:r>
+            <a:r>
+              <a:rPr lang="zh-TW" altLang="en-US" sz="2000" dirty="0"/>
+              <a:t> </a:t>
+            </a:r>
+            <a:r>
+              <a:rPr lang="en-US" sz="2000" dirty="0"/>
+              <a:t>DEBUG port →</a:t>
+            </a:r>
+            <a:r>
+              <a:rPr lang="zh-TW" altLang="en-US" sz="2000" dirty="0"/>
+              <a:t> </a:t>
+            </a:r>
+            <a:r>
+              <a:rPr lang="en-US" altLang="zh-TW" sz="2000" dirty="0"/>
+              <a:t>LMB</a:t>
+            </a:r>
+            <a:r>
+              <a:rPr lang="zh-TW" altLang="en-US" sz="2000" dirty="0"/>
+              <a:t> </a:t>
+            </a:r>
+            <a:r>
+              <a:rPr lang="en-US" altLang="zh-TW" sz="2000" dirty="0"/>
+              <a:t>Bus / AXI Bus</a:t>
+            </a:r>
+            <a:endParaRPr lang="en-US" sz="2000" dirty="0"/>
+          </a:p>
+        </p:txBody>
+      </p:sp>
+      <p:sp>
+        <p:nvSpPr>
+          <p:cNvPr id="4" name="投影片編號版面配置區 3">
+            <a:extLst>
+              <a:ext uri="{FF2B5EF4-FFF2-40B4-BE49-F238E27FC236}">
+                <a16:creationId xmlns:a16="http://schemas.microsoft.com/office/drawing/2014/main" id="{5423A423-83FD-700C-AC9E-87E02A890E3A}"/>
+              </a:ext>
+            </a:extLst>
+          </p:cNvPr>
+          <p:cNvSpPr>
+            <a:spLocks noGrp="1"/>
+          </p:cNvSpPr>
+          <p:nvPr>
+            <p:ph type="sldNum" sz="quarter" idx="12"/>
+          </p:nvPr>
+        </p:nvSpPr>
+        <p:spPr/>
+        <p:txBody>
+          <a:bodyPr/>
+          <a:lstStyle/>
+          <a:p>
+            <a:fld id="{F9F9ED32-46C6-469E-9D81-E8934DBD0961}" type="slidenum">
+              <a:rPr lang="zh-TW" altLang="en-US" smtClean="0"/>
+              <a:pPr/>
+              <a:t>15</a:t>
+            </a:fld>
+            <a:endParaRPr lang="zh-TW" altLang="en-US" dirty="0"/>
+          </a:p>
+        </p:txBody>
+      </p:sp>
+    </p:spTree>
+    <p:extLst>
+      <p:ext uri="{BB962C8B-B14F-4D97-AF65-F5344CB8AC3E}">
+        <p14:creationId xmlns:p14="http://schemas.microsoft.com/office/powerpoint/2010/main" val="121825054"/>
+      </p:ext>
+    </p:extLst>
+  </p:cSld>
+  <p:clrMapOvr>
+    <a:masterClrMapping/>
+  </p:clrMapOvr>
+</p:sld>
+</file>
+
+<file path=ppt/slides/slide16.xml><?xml version="1.0" encoding="utf-8"?>
+<p:sld xmlns:a="http://schemas.openxmlformats.org/drawingml/2006/main" xmlns:r="http://schemas.openxmlformats.org/officeDocument/2006/relationships" xmlns:p="http://schemas.openxmlformats.org/presentationml/2006/main">
+  <p:cSld>
+    <p:spTree>
+      <p:nvGrpSpPr>
         <p:cNvPr id="1" name="">
           <a:extLst>
             <a:ext uri="{FF2B5EF4-FFF2-40B4-BE49-F238E27FC236}">
@@ -8094,7 +8316,7 @@
               <a:rPr lang="en-TW" smtClean="0">
                 <a:latin typeface="+mn-lt"/>
               </a:rPr>
-              <a:t>15</a:t>
+              <a:t>16</a:t>
             </a:fld>
             <a:endParaRPr lang="en-TW">
               <a:latin typeface="+mn-lt"/>
@@ -8115,7 +8337,7 @@
 </p:sld>
 </file>
 
-<file path=ppt/slides/slide16.xml><?xml version="1.0" encoding="utf-8"?>
+<file path=ppt/slides/slide17.xml><?xml version="1.0" encoding="utf-8"?>
 <p:sld xmlns:a="http://schemas.openxmlformats.org/drawingml/2006/main" xmlns:r="http://schemas.openxmlformats.org/officeDocument/2006/relationships" xmlns:p="http://schemas.openxmlformats.org/presentationml/2006/main">
   <p:cSld>
     <p:spTree>
@@ -8192,7 +8414,7 @@
           <a:p>
             <a:fld id="{F9F9ED32-46C6-469E-9D81-E8934DBD0961}" type="slidenum">
               <a:rPr lang="zh-TW" altLang="en-US" smtClean="0"/>
-              <a:t>16</a:t>
+              <a:t>17</a:t>
             </a:fld>
             <a:endParaRPr lang="zh-TW" altLang="en-US" dirty="0"/>
           </a:p>
@@ -9633,7 +9855,7 @@
 </p:sld>
 </file>
 
-<file path=ppt/slides/slide17.xml><?xml version="1.0" encoding="utf-8"?>
+<file path=ppt/slides/slide18.xml><?xml version="1.0" encoding="utf-8"?>
 <p:sld xmlns:a="http://schemas.openxmlformats.org/drawingml/2006/main" xmlns:r="http://schemas.openxmlformats.org/officeDocument/2006/relationships" xmlns:p="http://schemas.openxmlformats.org/presentationml/2006/main">
   <p:cSld>
     <p:spTree>
@@ -9710,7 +9932,7 @@
           <a:p>
             <a:fld id="{F9F9ED32-46C6-469E-9D81-E8934DBD0961}" type="slidenum">
               <a:rPr lang="zh-TW" altLang="en-US" smtClean="0"/>
-              <a:t>17</a:t>
+              <a:t>18</a:t>
             </a:fld>
             <a:endParaRPr lang="zh-TW" altLang="en-US" dirty="0"/>
           </a:p>
@@ -10379,7 +10601,7 @@
 </p:sld>
 </file>
 
-<file path=ppt/slides/slide18.xml><?xml version="1.0" encoding="utf-8"?>
+<file path=ppt/slides/slide19.xml><?xml version="1.0" encoding="utf-8"?>
 <p:sld xmlns:a="http://schemas.openxmlformats.org/drawingml/2006/main" xmlns:r="http://schemas.openxmlformats.org/officeDocument/2006/relationships" xmlns:p="http://schemas.openxmlformats.org/presentationml/2006/main">
   <p:cSld>
     <p:spTree>
@@ -10599,7 +10821,7 @@
           <a:p>
             <a:fld id="{F9F9ED32-46C6-469E-9D81-E8934DBD0961}" type="slidenum">
               <a:rPr lang="zh-TW" altLang="en-US" smtClean="0"/>
-              <a:t>18</a:t>
+              <a:t>19</a:t>
             </a:fld>
             <a:endParaRPr lang="zh-TW" altLang="en-US" dirty="0"/>
           </a:p>
@@ -10721,7 +10943,278 @@
 </p:sld>
 </file>
 
-<file path=ppt/slides/slide19.xml><?xml version="1.0" encoding="utf-8"?>
+<file path=ppt/slides/slide2.xml><?xml version="1.0" encoding="utf-8"?>
+<p:sld xmlns:a="http://schemas.openxmlformats.org/drawingml/2006/main" xmlns:r="http://schemas.openxmlformats.org/officeDocument/2006/relationships" xmlns:p="http://schemas.openxmlformats.org/presentationml/2006/main">
+  <p:cSld>
+    <p:spTree>
+      <p:nvGrpSpPr>
+        <p:cNvPr id="1" name="">
+          <a:extLst>
+            <a:ext uri="{FF2B5EF4-FFF2-40B4-BE49-F238E27FC236}">
+              <a16:creationId xmlns:a16="http://schemas.microsoft.com/office/drawing/2014/main" id="{B69280E7-411B-5B87-EFAC-03C9325D8EB4}"/>
+            </a:ext>
+          </a:extLst>
+        </p:cNvPr>
+        <p:cNvGrpSpPr/>
+        <p:nvPr/>
+      </p:nvGrpSpPr>
+      <p:grpSpPr>
+        <a:xfrm>
+          <a:off x="0" y="0"/>
+          <a:ext cx="0" cy="0"/>
+          <a:chOff x="0" y="0"/>
+          <a:chExt cx="0" cy="0"/>
+        </a:xfrm>
+      </p:grpSpPr>
+      <p:sp>
+        <p:nvSpPr>
+          <p:cNvPr id="2" name="標題 1">
+            <a:extLst>
+              <a:ext uri="{FF2B5EF4-FFF2-40B4-BE49-F238E27FC236}">
+                <a16:creationId xmlns:a16="http://schemas.microsoft.com/office/drawing/2014/main" id="{4743D012-99B4-A6AC-0CD2-999158835AC4}"/>
+              </a:ext>
+            </a:extLst>
+          </p:cNvPr>
+          <p:cNvSpPr>
+            <a:spLocks noGrp="1"/>
+          </p:cNvSpPr>
+          <p:nvPr>
+            <p:ph type="title"/>
+          </p:nvPr>
+        </p:nvSpPr>
+        <p:spPr/>
+        <p:txBody>
+          <a:bodyPr/>
+          <a:lstStyle/>
+          <a:p>
+            <a:r>
+              <a:rPr lang="en-US" altLang="zh-TW" dirty="0"/>
+              <a:t>Outline</a:t>
+            </a:r>
+            <a:endParaRPr lang="zh-TW" altLang="en-US" dirty="0"/>
+          </a:p>
+        </p:txBody>
+      </p:sp>
+      <p:sp>
+        <p:nvSpPr>
+          <p:cNvPr id="3" name="內容版面配置區 2">
+            <a:extLst>
+              <a:ext uri="{FF2B5EF4-FFF2-40B4-BE49-F238E27FC236}">
+                <a16:creationId xmlns:a16="http://schemas.microsoft.com/office/drawing/2014/main" id="{130A0642-98CF-9CEF-6C6D-052CB538B24A}"/>
+              </a:ext>
+            </a:extLst>
+          </p:cNvPr>
+          <p:cNvSpPr>
+            <a:spLocks noGrp="1"/>
+          </p:cNvSpPr>
+          <p:nvPr>
+            <p:ph idx="1"/>
+          </p:nvPr>
+        </p:nvSpPr>
+        <p:spPr/>
+        <p:txBody>
+          <a:bodyPr/>
+          <a:lstStyle/>
+          <a:p>
+            <a:pPr>
+              <a:spcBef>
+                <a:spcPts val="1200"/>
+              </a:spcBef>
+            </a:pPr>
+            <a:r>
+              <a:rPr lang="en-US" sz="2400" dirty="0">
+                <a:latin typeface="Times New Roman" panose="02020603050405020304" pitchFamily="18" charset="0"/>
+                <a:cs typeface="Times New Roman" panose="02020603050405020304" pitchFamily="18" charset="0"/>
+              </a:rPr>
+              <a:t>FPGA Selection and Spec</a:t>
+            </a:r>
+          </a:p>
+          <a:p>
+            <a:pPr>
+              <a:spcBef>
+                <a:spcPts val="1200"/>
+              </a:spcBef>
+            </a:pPr>
+            <a:r>
+              <a:rPr lang="en-US" sz="2400" dirty="0">
+                <a:latin typeface="Times New Roman" panose="02020603050405020304" pitchFamily="18" charset="0"/>
+                <a:cs typeface="Times New Roman" panose="02020603050405020304" pitchFamily="18" charset="0"/>
+              </a:rPr>
+              <a:t>Microcontroller Overview</a:t>
+            </a:r>
+            <a:endParaRPr lang="en-US" sz="2400" dirty="0">
+              <a:solidFill>
+                <a:schemeClr val="bg2"/>
+              </a:solidFill>
+              <a:latin typeface="Times New Roman" panose="02020603050405020304" pitchFamily="18" charset="0"/>
+              <a:cs typeface="Times New Roman" panose="02020603050405020304" pitchFamily="18" charset="0"/>
+            </a:endParaRPr>
+          </a:p>
+          <a:p>
+            <a:pPr>
+              <a:spcBef>
+                <a:spcPts val="1200"/>
+              </a:spcBef>
+            </a:pPr>
+            <a:r>
+              <a:rPr lang="en-US" sz="2400" dirty="0">
+                <a:latin typeface="Times New Roman" panose="02020603050405020304" pitchFamily="18" charset="0"/>
+                <a:cs typeface="Times New Roman" panose="02020603050405020304" pitchFamily="18" charset="0"/>
+              </a:rPr>
+              <a:t>MDM / GPIO / Interrupt System / </a:t>
+            </a:r>
+            <a:r>
+              <a:rPr lang="zh-TW" altLang="en-US" sz="2400" dirty="0">
+                <a:latin typeface="Times New Roman" panose="02020603050405020304" pitchFamily="18" charset="0"/>
+                <a:cs typeface="Times New Roman" panose="02020603050405020304" pitchFamily="18" charset="0"/>
+              </a:rPr>
+              <a:t> </a:t>
+            </a:r>
+            <a:r>
+              <a:rPr lang="en-US" altLang="zh-TW" sz="2400" dirty="0">
+                <a:latin typeface="Times New Roman" panose="02020603050405020304" pitchFamily="18" charset="0"/>
+                <a:cs typeface="Times New Roman" panose="02020603050405020304" pitchFamily="18" charset="0"/>
+              </a:rPr>
+              <a:t>Timer &amp; PWM / XADC / UART</a:t>
+            </a:r>
+          </a:p>
+          <a:p>
+            <a:pPr>
+              <a:spcBef>
+                <a:spcPts val="1200"/>
+              </a:spcBef>
+            </a:pPr>
+            <a:r>
+              <a:rPr lang="en-US" altLang="zh-TW" sz="2400" dirty="0">
+                <a:solidFill>
+                  <a:srgbClr val="FF0000"/>
+                </a:solidFill>
+                <a:latin typeface="Times New Roman" panose="02020603050405020304" pitchFamily="18" charset="0"/>
+                <a:cs typeface="Times New Roman" panose="02020603050405020304" pitchFamily="18" charset="0"/>
+              </a:rPr>
+              <a:t>Memory Hierarchy</a:t>
+            </a:r>
+          </a:p>
+          <a:p>
+            <a:pPr>
+              <a:spcBef>
+                <a:spcPts val="1200"/>
+              </a:spcBef>
+            </a:pPr>
+            <a:r>
+              <a:rPr lang="en-US" altLang="zh-TW" sz="2400" dirty="0">
+                <a:latin typeface="Times New Roman" panose="02020603050405020304" pitchFamily="18" charset="0"/>
+                <a:cs typeface="Times New Roman" panose="02020603050405020304" pitchFamily="18" charset="0"/>
+              </a:rPr>
+              <a:t>Hardware Report</a:t>
+            </a:r>
+            <a:endParaRPr lang="en-US" sz="2400" dirty="0">
+              <a:latin typeface="Times New Roman" panose="02020603050405020304" pitchFamily="18" charset="0"/>
+              <a:cs typeface="Times New Roman" panose="02020603050405020304" pitchFamily="18" charset="0"/>
+            </a:endParaRPr>
+          </a:p>
+          <a:p>
+            <a:pPr>
+              <a:spcBef>
+                <a:spcPts val="1200"/>
+              </a:spcBef>
+            </a:pPr>
+            <a:r>
+              <a:rPr lang="en-US" sz="2400" dirty="0">
+                <a:latin typeface="Times New Roman" panose="02020603050405020304" pitchFamily="18" charset="0"/>
+                <a:cs typeface="Times New Roman" panose="02020603050405020304" pitchFamily="18" charset="0"/>
+              </a:rPr>
+              <a:t>Software Design Flow</a:t>
+            </a:r>
+          </a:p>
+          <a:p>
+            <a:pPr>
+              <a:spcBef>
+                <a:spcPts val="1200"/>
+              </a:spcBef>
+            </a:pPr>
+            <a:r>
+              <a:rPr lang="en-US" sz="2400" dirty="0">
+                <a:latin typeface="Times New Roman" panose="02020603050405020304" pitchFamily="18" charset="0"/>
+                <a:cs typeface="Times New Roman" panose="02020603050405020304" pitchFamily="18" charset="0"/>
+              </a:rPr>
+              <a:t>JTAG Debug Flow</a:t>
+            </a:r>
+          </a:p>
+          <a:p>
+            <a:pPr>
+              <a:spcBef>
+                <a:spcPts val="1200"/>
+              </a:spcBef>
+            </a:pPr>
+            <a:r>
+              <a:rPr lang="en-US" sz="2400" dirty="0">
+                <a:solidFill>
+                  <a:srgbClr val="FF0000"/>
+                </a:solidFill>
+                <a:latin typeface="Times New Roman" panose="02020603050405020304" pitchFamily="18" charset="0"/>
+                <a:cs typeface="Times New Roman" panose="02020603050405020304" pitchFamily="18" charset="0"/>
+              </a:rPr>
+              <a:t>Standalone Boot Sequence</a:t>
+            </a:r>
+          </a:p>
+        </p:txBody>
+      </p:sp>
+      <p:sp>
+        <p:nvSpPr>
+          <p:cNvPr id="4" name="投影片編號版面配置區 3">
+            <a:extLst>
+              <a:ext uri="{FF2B5EF4-FFF2-40B4-BE49-F238E27FC236}">
+                <a16:creationId xmlns:a16="http://schemas.microsoft.com/office/drawing/2014/main" id="{2026C914-5B87-BB1E-25CB-FED0FD0FBFCC}"/>
+              </a:ext>
+            </a:extLst>
+          </p:cNvPr>
+          <p:cNvSpPr>
+            <a:spLocks noGrp="1"/>
+          </p:cNvSpPr>
+          <p:nvPr>
+            <p:ph type="sldNum" sz="quarter" idx="12"/>
+          </p:nvPr>
+        </p:nvSpPr>
+        <p:spPr/>
+        <p:txBody>
+          <a:bodyPr/>
+          <a:lstStyle/>
+          <a:p>
+            <a:fld id="{F9F9ED32-46C6-469E-9D81-E8934DBD0961}" type="slidenum">
+              <a:rPr lang="zh-TW" altLang="en-US" smtClean="0"/>
+              <a:t>2</a:t>
+            </a:fld>
+            <a:endParaRPr lang="zh-TW" altLang="en-US" dirty="0"/>
+          </a:p>
+        </p:txBody>
+      </p:sp>
+    </p:spTree>
+    <p:extLst>
+      <p:ext uri="{BB962C8B-B14F-4D97-AF65-F5344CB8AC3E}">
+        <p14:creationId xmlns:p14="http://schemas.microsoft.com/office/powerpoint/2010/main" val="219506187"/>
+      </p:ext>
+    </p:extLst>
+  </p:cSld>
+  <p:clrMapOvr>
+    <a:masterClrMapping/>
+  </p:clrMapOvr>
+  <mc:AlternateContent xmlns:mc="http://schemas.openxmlformats.org/markup-compatibility/2006" xmlns:p14="http://schemas.microsoft.com/office/powerpoint/2010/main">
+    <mc:Choice Requires="p14">
+      <p:transition spd="slow" p14:dur="2000">
+        <p:cut/>
+      </p:transition>
+    </mc:Choice>
+    <mc:Fallback xmlns="">
+      <p:transition spd="slow">
+        <p:cut/>
+      </p:transition>
+    </mc:Fallback>
+  </mc:AlternateContent>
+</p:sld>
+</file>
+
+<file path=ppt/slides/slide20.xml><?xml version="1.0" encoding="utf-8"?>
 <p:sld xmlns:a="http://schemas.openxmlformats.org/drawingml/2006/main" xmlns:r="http://schemas.openxmlformats.org/officeDocument/2006/relationships" xmlns:p="http://schemas.openxmlformats.org/presentationml/2006/main">
   <p:cSld>
     <p:spTree>
@@ -10789,7 +11282,7 @@
           <a:p>
             <a:fld id="{5E7A655E-BA10-45EB-B439-1EA08694B58E}" type="slidenum">
               <a:rPr lang="en-US" smtClean="0"/>
-              <a:t>19</a:t>
+              <a:t>20</a:t>
             </a:fld>
             <a:endParaRPr lang="en-US"/>
           </a:p>
@@ -12672,278 +13165,7 @@
 </p:sld>
 </file>
 
-<file path=ppt/slides/slide2.xml><?xml version="1.0" encoding="utf-8"?>
-<p:sld xmlns:a="http://schemas.openxmlformats.org/drawingml/2006/main" xmlns:r="http://schemas.openxmlformats.org/officeDocument/2006/relationships" xmlns:p="http://schemas.openxmlformats.org/presentationml/2006/main">
-  <p:cSld>
-    <p:spTree>
-      <p:nvGrpSpPr>
-        <p:cNvPr id="1" name="">
-          <a:extLst>
-            <a:ext uri="{FF2B5EF4-FFF2-40B4-BE49-F238E27FC236}">
-              <a16:creationId xmlns:a16="http://schemas.microsoft.com/office/drawing/2014/main" id="{B69280E7-411B-5B87-EFAC-03C9325D8EB4}"/>
-            </a:ext>
-          </a:extLst>
-        </p:cNvPr>
-        <p:cNvGrpSpPr/>
-        <p:nvPr/>
-      </p:nvGrpSpPr>
-      <p:grpSpPr>
-        <a:xfrm>
-          <a:off x="0" y="0"/>
-          <a:ext cx="0" cy="0"/>
-          <a:chOff x="0" y="0"/>
-          <a:chExt cx="0" cy="0"/>
-        </a:xfrm>
-      </p:grpSpPr>
-      <p:sp>
-        <p:nvSpPr>
-          <p:cNvPr id="2" name="標題 1">
-            <a:extLst>
-              <a:ext uri="{FF2B5EF4-FFF2-40B4-BE49-F238E27FC236}">
-                <a16:creationId xmlns:a16="http://schemas.microsoft.com/office/drawing/2014/main" id="{4743D012-99B4-A6AC-0CD2-999158835AC4}"/>
-              </a:ext>
-            </a:extLst>
-          </p:cNvPr>
-          <p:cNvSpPr>
-            <a:spLocks noGrp="1"/>
-          </p:cNvSpPr>
-          <p:nvPr>
-            <p:ph type="title"/>
-          </p:nvPr>
-        </p:nvSpPr>
-        <p:spPr/>
-        <p:txBody>
-          <a:bodyPr/>
-          <a:lstStyle/>
-          <a:p>
-            <a:r>
-              <a:rPr lang="en-US" altLang="zh-TW" dirty="0"/>
-              <a:t>Outline</a:t>
-            </a:r>
-            <a:endParaRPr lang="zh-TW" altLang="en-US" dirty="0"/>
-          </a:p>
-        </p:txBody>
-      </p:sp>
-      <p:sp>
-        <p:nvSpPr>
-          <p:cNvPr id="3" name="內容版面配置區 2">
-            <a:extLst>
-              <a:ext uri="{FF2B5EF4-FFF2-40B4-BE49-F238E27FC236}">
-                <a16:creationId xmlns:a16="http://schemas.microsoft.com/office/drawing/2014/main" id="{130A0642-98CF-9CEF-6C6D-052CB538B24A}"/>
-              </a:ext>
-            </a:extLst>
-          </p:cNvPr>
-          <p:cNvSpPr>
-            <a:spLocks noGrp="1"/>
-          </p:cNvSpPr>
-          <p:nvPr>
-            <p:ph idx="1"/>
-          </p:nvPr>
-        </p:nvSpPr>
-        <p:spPr/>
-        <p:txBody>
-          <a:bodyPr/>
-          <a:lstStyle/>
-          <a:p>
-            <a:pPr>
-              <a:spcBef>
-                <a:spcPts val="1200"/>
-              </a:spcBef>
-            </a:pPr>
-            <a:r>
-              <a:rPr lang="en-US" sz="2400" dirty="0">
-                <a:latin typeface="Times New Roman" panose="02020603050405020304" pitchFamily="18" charset="0"/>
-                <a:cs typeface="Times New Roman" panose="02020603050405020304" pitchFamily="18" charset="0"/>
-              </a:rPr>
-              <a:t>FPGA Selection and Spec</a:t>
-            </a:r>
-          </a:p>
-          <a:p>
-            <a:pPr>
-              <a:spcBef>
-                <a:spcPts val="1200"/>
-              </a:spcBef>
-            </a:pPr>
-            <a:r>
-              <a:rPr lang="en-US" sz="2400" dirty="0">
-                <a:latin typeface="Times New Roman" panose="02020603050405020304" pitchFamily="18" charset="0"/>
-                <a:cs typeface="Times New Roman" panose="02020603050405020304" pitchFamily="18" charset="0"/>
-              </a:rPr>
-              <a:t>Microcontroller Overview</a:t>
-            </a:r>
-            <a:endParaRPr lang="en-US" sz="2400" dirty="0">
-              <a:solidFill>
-                <a:schemeClr val="bg2"/>
-              </a:solidFill>
-              <a:latin typeface="Times New Roman" panose="02020603050405020304" pitchFamily="18" charset="0"/>
-              <a:cs typeface="Times New Roman" panose="02020603050405020304" pitchFamily="18" charset="0"/>
-            </a:endParaRPr>
-          </a:p>
-          <a:p>
-            <a:pPr>
-              <a:spcBef>
-                <a:spcPts val="1200"/>
-              </a:spcBef>
-            </a:pPr>
-            <a:r>
-              <a:rPr lang="en-US" sz="2400" dirty="0">
-                <a:latin typeface="Times New Roman" panose="02020603050405020304" pitchFamily="18" charset="0"/>
-                <a:cs typeface="Times New Roman" panose="02020603050405020304" pitchFamily="18" charset="0"/>
-              </a:rPr>
-              <a:t>GPIO / Interrupt System / </a:t>
-            </a:r>
-            <a:r>
-              <a:rPr lang="zh-TW" altLang="en-US" sz="2400" dirty="0">
-                <a:latin typeface="Times New Roman" panose="02020603050405020304" pitchFamily="18" charset="0"/>
-                <a:cs typeface="Times New Roman" panose="02020603050405020304" pitchFamily="18" charset="0"/>
-              </a:rPr>
-              <a:t> </a:t>
-            </a:r>
-            <a:r>
-              <a:rPr lang="en-US" altLang="zh-TW" sz="2400" dirty="0">
-                <a:latin typeface="Times New Roman" panose="02020603050405020304" pitchFamily="18" charset="0"/>
-                <a:cs typeface="Times New Roman" panose="02020603050405020304" pitchFamily="18" charset="0"/>
-              </a:rPr>
-              <a:t>Timer &amp; PWM / XADC / UART</a:t>
-            </a:r>
-          </a:p>
-          <a:p>
-            <a:pPr>
-              <a:spcBef>
-                <a:spcPts val="1200"/>
-              </a:spcBef>
-            </a:pPr>
-            <a:r>
-              <a:rPr lang="en-US" altLang="zh-TW" sz="2400" dirty="0">
-                <a:solidFill>
-                  <a:srgbClr val="FF0000"/>
-                </a:solidFill>
-                <a:latin typeface="Times New Roman" panose="02020603050405020304" pitchFamily="18" charset="0"/>
-                <a:cs typeface="Times New Roman" panose="02020603050405020304" pitchFamily="18" charset="0"/>
-              </a:rPr>
-              <a:t>Memory Hierarchy</a:t>
-            </a:r>
-          </a:p>
-          <a:p>
-            <a:pPr>
-              <a:spcBef>
-                <a:spcPts val="1200"/>
-              </a:spcBef>
-            </a:pPr>
-            <a:r>
-              <a:rPr lang="en-US" altLang="zh-TW" sz="2400" dirty="0">
-                <a:latin typeface="Times New Roman" panose="02020603050405020304" pitchFamily="18" charset="0"/>
-                <a:cs typeface="Times New Roman" panose="02020603050405020304" pitchFamily="18" charset="0"/>
-              </a:rPr>
-              <a:t>Hardware Report</a:t>
-            </a:r>
-            <a:endParaRPr lang="en-US" sz="2400" dirty="0">
-              <a:latin typeface="Times New Roman" panose="02020603050405020304" pitchFamily="18" charset="0"/>
-              <a:cs typeface="Times New Roman" panose="02020603050405020304" pitchFamily="18" charset="0"/>
-            </a:endParaRPr>
-          </a:p>
-          <a:p>
-            <a:pPr>
-              <a:spcBef>
-                <a:spcPts val="1200"/>
-              </a:spcBef>
-            </a:pPr>
-            <a:r>
-              <a:rPr lang="en-US" sz="2400" dirty="0">
-                <a:latin typeface="Times New Roman" panose="02020603050405020304" pitchFamily="18" charset="0"/>
-                <a:cs typeface="Times New Roman" panose="02020603050405020304" pitchFamily="18" charset="0"/>
-              </a:rPr>
-              <a:t>Software Design Flow</a:t>
-            </a:r>
-          </a:p>
-          <a:p>
-            <a:pPr>
-              <a:spcBef>
-                <a:spcPts val="1200"/>
-              </a:spcBef>
-            </a:pPr>
-            <a:r>
-              <a:rPr lang="en-US" sz="2400" dirty="0">
-                <a:latin typeface="Times New Roman" panose="02020603050405020304" pitchFamily="18" charset="0"/>
-                <a:cs typeface="Times New Roman" panose="02020603050405020304" pitchFamily="18" charset="0"/>
-              </a:rPr>
-              <a:t>JTAG Debug Flow</a:t>
-            </a:r>
-          </a:p>
-          <a:p>
-            <a:pPr>
-              <a:spcBef>
-                <a:spcPts val="1200"/>
-              </a:spcBef>
-            </a:pPr>
-            <a:r>
-              <a:rPr lang="en-US" sz="2400" dirty="0">
-                <a:solidFill>
-                  <a:srgbClr val="FF0000"/>
-                </a:solidFill>
-                <a:latin typeface="Times New Roman" panose="02020603050405020304" pitchFamily="18" charset="0"/>
-                <a:cs typeface="Times New Roman" panose="02020603050405020304" pitchFamily="18" charset="0"/>
-              </a:rPr>
-              <a:t>Standalone Boot Sequence</a:t>
-            </a:r>
-          </a:p>
-        </p:txBody>
-      </p:sp>
-      <p:sp>
-        <p:nvSpPr>
-          <p:cNvPr id="4" name="投影片編號版面配置區 3">
-            <a:extLst>
-              <a:ext uri="{FF2B5EF4-FFF2-40B4-BE49-F238E27FC236}">
-                <a16:creationId xmlns:a16="http://schemas.microsoft.com/office/drawing/2014/main" id="{2026C914-5B87-BB1E-25CB-FED0FD0FBFCC}"/>
-              </a:ext>
-            </a:extLst>
-          </p:cNvPr>
-          <p:cNvSpPr>
-            <a:spLocks noGrp="1"/>
-          </p:cNvSpPr>
-          <p:nvPr>
-            <p:ph type="sldNum" sz="quarter" idx="12"/>
-          </p:nvPr>
-        </p:nvSpPr>
-        <p:spPr/>
-        <p:txBody>
-          <a:bodyPr/>
-          <a:lstStyle/>
-          <a:p>
-            <a:fld id="{F9F9ED32-46C6-469E-9D81-E8934DBD0961}" type="slidenum">
-              <a:rPr lang="zh-TW" altLang="en-US" smtClean="0"/>
-              <a:t>2</a:t>
-            </a:fld>
-            <a:endParaRPr lang="zh-TW" altLang="en-US" dirty="0"/>
-          </a:p>
-        </p:txBody>
-      </p:sp>
-    </p:spTree>
-    <p:extLst>
-      <p:ext uri="{BB962C8B-B14F-4D97-AF65-F5344CB8AC3E}">
-        <p14:creationId xmlns:p14="http://schemas.microsoft.com/office/powerpoint/2010/main" val="219506187"/>
-      </p:ext>
-    </p:extLst>
-  </p:cSld>
-  <p:clrMapOvr>
-    <a:masterClrMapping/>
-  </p:clrMapOvr>
-  <mc:AlternateContent xmlns:mc="http://schemas.openxmlformats.org/markup-compatibility/2006" xmlns:p14="http://schemas.microsoft.com/office/powerpoint/2010/main">
-    <mc:Choice Requires="p14">
-      <p:transition spd="slow" p14:dur="2000">
-        <p:cut/>
-      </p:transition>
-    </mc:Choice>
-    <mc:Fallback xmlns="">
-      <p:transition spd="slow">
-        <p:cut/>
-      </p:transition>
-    </mc:Fallback>
-  </mc:AlternateContent>
-</p:sld>
-</file>
-
-<file path=ppt/slides/slide20.xml><?xml version="1.0" encoding="utf-8"?>
+<file path=ppt/slides/slide21.xml><?xml version="1.0" encoding="utf-8"?>
 <p:sld xmlns:a="http://schemas.openxmlformats.org/drawingml/2006/main" xmlns:r="http://schemas.openxmlformats.org/officeDocument/2006/relationships" xmlns:p="http://schemas.openxmlformats.org/presentationml/2006/main">
   <p:cSld>
     <p:spTree>
@@ -13034,7 +13256,7 @@
                 <a:latin typeface="Times New Roman" panose="02020603050405020304" pitchFamily="18" charset="0"/>
                 <a:cs typeface="Times New Roman" panose="02020603050405020304" pitchFamily="18" charset="0"/>
               </a:rPr>
-              <a:t>GPIO / Interrupt System / </a:t>
+              <a:t>MDM / GPIO / Interrupt System / </a:t>
             </a:r>
             <a:r>
               <a:rPr lang="zh-TW" altLang="en-US" sz="2400" dirty="0">
@@ -13171,7 +13393,7 @@
           <a:p>
             <a:fld id="{F9F9ED32-46C6-469E-9D81-E8934DBD0961}" type="slidenum">
               <a:rPr lang="zh-TW" altLang="en-US" smtClean="0"/>
-              <a:t>20</a:t>
+              <a:t>21</a:t>
             </a:fld>
             <a:endParaRPr lang="zh-TW" altLang="en-US" dirty="0"/>
           </a:p>
@@ -13202,7 +13424,7 @@
 </p:sld>
 </file>
 
-<file path=ppt/slides/slide21.xml><?xml version="1.0" encoding="utf-8"?>
+<file path=ppt/slides/slide22.xml><?xml version="1.0" encoding="utf-8"?>
 <p:sld xmlns:a="http://schemas.openxmlformats.org/drawingml/2006/main" xmlns:r="http://schemas.openxmlformats.org/officeDocument/2006/relationships" xmlns:p="http://schemas.openxmlformats.org/presentationml/2006/main">
   <p:cSld>
     <p:spTree>
@@ -13276,7 +13498,7 @@
           <a:p>
             <a:fld id="{9856DA5A-CF52-47BD-AC49-21DC5CAD2230}" type="slidenum">
               <a:rPr lang="en-TW" smtClean="0"/>
-              <a:t>21</a:t>
+              <a:t>22</a:t>
             </a:fld>
             <a:endParaRPr lang="en-TW"/>
           </a:p>
@@ -13342,7 +13564,7 @@
 </p:sld>
 </file>
 
-<file path=ppt/slides/slide22.xml><?xml version="1.0" encoding="utf-8"?>
+<file path=ppt/slides/slide23.xml><?xml version="1.0" encoding="utf-8"?>
 <p:sld xmlns:a="http://schemas.openxmlformats.org/drawingml/2006/main" xmlns:r="http://schemas.openxmlformats.org/officeDocument/2006/relationships" xmlns:p="http://schemas.openxmlformats.org/presentationml/2006/main">
   <p:cSld>
     <p:spTree>
@@ -13433,7 +13655,7 @@
                 <a:latin typeface="Times New Roman" panose="02020603050405020304" pitchFamily="18" charset="0"/>
                 <a:cs typeface="Times New Roman" panose="02020603050405020304" pitchFamily="18" charset="0"/>
               </a:rPr>
-              <a:t>GPIO / Interrupt System / </a:t>
+              <a:t>MDM / GPIO / Interrupt System / </a:t>
             </a:r>
             <a:r>
               <a:rPr lang="zh-TW" altLang="en-US" sz="2400" dirty="0">
@@ -13567,7 +13789,7 @@
           <a:p>
             <a:fld id="{F9F9ED32-46C6-469E-9D81-E8934DBD0961}" type="slidenum">
               <a:rPr lang="zh-TW" altLang="en-US" smtClean="0"/>
-              <a:t>22</a:t>
+              <a:t>23</a:t>
             </a:fld>
             <a:endParaRPr lang="zh-TW" altLang="en-US" dirty="0"/>
           </a:p>
@@ -13598,7 +13820,7 @@
 </p:sld>
 </file>
 
-<file path=ppt/slides/slide23.xml><?xml version="1.0" encoding="utf-8"?>
+<file path=ppt/slides/slide24.xml><?xml version="1.0" encoding="utf-8"?>
 <p:sld xmlns:a="http://schemas.openxmlformats.org/drawingml/2006/main" xmlns:r="http://schemas.openxmlformats.org/officeDocument/2006/relationships" xmlns:p="http://schemas.openxmlformats.org/presentationml/2006/main">
   <p:cSld>
     <p:spTree>
@@ -13838,7 +14060,7 @@
           <a:p>
             <a:fld id="{5E7A655E-BA10-45EB-B439-1EA08694B58E}" type="slidenum">
               <a:rPr lang="en-TW" smtClean="0"/>
-              <a:t>23</a:t>
+              <a:t>24</a:t>
             </a:fld>
             <a:endParaRPr lang="en-TW"/>
           </a:p>
@@ -13852,7 +14074,7 @@
 </p:sld>
 </file>
 
-<file path=ppt/slides/slide24.xml><?xml version="1.0" encoding="utf-8"?>
+<file path=ppt/slides/slide25.xml><?xml version="1.0" encoding="utf-8"?>
 <p:sld xmlns:a="http://schemas.openxmlformats.org/drawingml/2006/main" xmlns:r="http://schemas.openxmlformats.org/officeDocument/2006/relationships" xmlns:p="http://schemas.openxmlformats.org/presentationml/2006/main">
   <p:cSld>
     <p:spTree>
@@ -13943,7 +14165,7 @@
                 <a:latin typeface="Times New Roman" panose="02020603050405020304" pitchFamily="18" charset="0"/>
                 <a:cs typeface="Times New Roman" panose="02020603050405020304" pitchFamily="18" charset="0"/>
               </a:rPr>
-              <a:t>GPIO / Interrupt System / </a:t>
+              <a:t>MDM / GPIO / Interrupt System / </a:t>
             </a:r>
             <a:r>
               <a:rPr lang="zh-TW" altLang="en-US" sz="2400" dirty="0">
@@ -14080,7 +14302,7 @@
           <a:p>
             <a:fld id="{F9F9ED32-46C6-469E-9D81-E8934DBD0961}" type="slidenum">
               <a:rPr lang="zh-TW" altLang="en-US" smtClean="0"/>
-              <a:t>24</a:t>
+              <a:t>25</a:t>
             </a:fld>
             <a:endParaRPr lang="zh-TW" altLang="en-US" dirty="0"/>
           </a:p>
@@ -14111,7 +14333,7 @@
 </p:sld>
 </file>
 
-<file path=ppt/slides/slide25.xml><?xml version="1.0" encoding="utf-8"?>
+<file path=ppt/slides/slide26.xml><?xml version="1.0" encoding="utf-8"?>
 <p:sld xmlns:a="http://schemas.openxmlformats.org/drawingml/2006/main" xmlns:r="http://schemas.openxmlformats.org/officeDocument/2006/relationships" xmlns:p="http://schemas.openxmlformats.org/presentationml/2006/main">
   <p:cSld>
     <p:spTree>
@@ -14235,7 +14457,7 @@
             </a:pPr>
             <a:fld id="{00000000-1234-1234-1234-123412341234}" type="slidenum">
               <a:rPr lang="en-US" smtClean="0"/>
-              <a:t>25</a:t>
+              <a:t>26</a:t>
             </a:fld>
             <a:endParaRPr lang="en-US"/>
           </a:p>
@@ -14254,7 +14476,7 @@
 </p:sld>
 </file>
 
-<file path=ppt/slides/slide26.xml><?xml version="1.0" encoding="utf-8"?>
+<file path=ppt/slides/slide27.xml><?xml version="1.0" encoding="utf-8"?>
 <p:sld xmlns:a="http://schemas.openxmlformats.org/drawingml/2006/main" xmlns:r="http://schemas.openxmlformats.org/officeDocument/2006/relationships" xmlns:p="http://schemas.openxmlformats.org/presentationml/2006/main">
   <p:cSld>
     <p:spTree>
@@ -14489,7 +14711,7 @@
             </a:pPr>
             <a:fld id="{00000000-1234-1234-1234-123412341234}" type="slidenum">
               <a:rPr lang="en-US" smtClean="0"/>
-              <a:t>26</a:t>
+              <a:t>27</a:t>
             </a:fld>
             <a:endParaRPr lang="en-US"/>
           </a:p>
@@ -14508,7 +14730,7 @@
 </p:sld>
 </file>
 
-<file path=ppt/slides/slide27.xml><?xml version="1.0" encoding="utf-8"?>
+<file path=ppt/slides/slide28.xml><?xml version="1.0" encoding="utf-8"?>
 <p:sld xmlns:a="http://schemas.openxmlformats.org/drawingml/2006/main" xmlns:r="http://schemas.openxmlformats.org/officeDocument/2006/relationships" xmlns:p="http://schemas.openxmlformats.org/presentationml/2006/main">
   <p:cSld>
     <p:spTree>
@@ -14785,7 +15007,7 @@
             <a:fld id="{F9F9ED32-46C6-469E-9D81-E8934DBD0961}" type="slidenum">
               <a:rPr lang="zh-TW" altLang="en-US" smtClean="0"/>
               <a:pPr/>
-              <a:t>27</a:t>
+              <a:t>28</a:t>
             </a:fld>
             <a:endParaRPr lang="zh-TW" altLang="en-US" dirty="0"/>
           </a:p>
@@ -14880,7 +15102,7 @@
 </p:sld>
 </file>
 
-<file path=ppt/slides/slide28.xml><?xml version="1.0" encoding="utf-8"?>
+<file path=ppt/slides/slide29.xml><?xml version="1.0" encoding="utf-8"?>
 <p:sld xmlns:a="http://schemas.openxmlformats.org/drawingml/2006/main" xmlns:r="http://schemas.openxmlformats.org/officeDocument/2006/relationships" xmlns:p="http://schemas.openxmlformats.org/presentationml/2006/main">
   <p:cSld>
     <p:spTree>
@@ -15010,23 +15232,7 @@
             <a:pPr lvl="1"/>
             <a:r>
               <a:rPr lang="en-US" sz="2000" dirty="0"/>
-              <a:t>Connects to </a:t>
-            </a:r>
-            <a:r>
-              <a:rPr lang="en-US" sz="2000" dirty="0" err="1"/>
-              <a:t>MicroBlaze</a:t>
-            </a:r>
-            <a:r>
-              <a:rPr lang="en-US" sz="2000" dirty="0"/>
-              <a:t> via MDM (</a:t>
-            </a:r>
-            <a:r>
-              <a:rPr lang="en-US" sz="2000" dirty="0" err="1"/>
-              <a:t>MicroBlaze</a:t>
-            </a:r>
-            <a:r>
-              <a:rPr lang="en-US" sz="2000" dirty="0"/>
-              <a:t> Debug Module)</a:t>
+              <a:t>Connects to MicroBlaze via MDM (MicroBlaze Debug Module)</a:t>
             </a:r>
           </a:p>
           <a:p>
@@ -15120,7 +15326,7 @@
             <a:fld id="{F9F9ED32-46C6-469E-9D81-E8934DBD0961}" type="slidenum">
               <a:rPr lang="zh-TW" altLang="en-US" smtClean="0"/>
               <a:pPr/>
-              <a:t>28</a:t>
+              <a:t>29</a:t>
             </a:fld>
             <a:endParaRPr lang="zh-TW" altLang="en-US" dirty="0"/>
           </a:p>
@@ -15136,265 +15342,6 @@
   <p:clrMapOvr>
     <a:masterClrMapping/>
   </p:clrMapOvr>
-</p:sld>
-</file>
-
-<file path=ppt/slides/slide29.xml><?xml version="1.0" encoding="utf-8"?>
-<p:sld xmlns:a="http://schemas.openxmlformats.org/drawingml/2006/main" xmlns:r="http://schemas.openxmlformats.org/officeDocument/2006/relationships" xmlns:p="http://schemas.openxmlformats.org/presentationml/2006/main">
-  <p:cSld>
-    <p:spTree>
-      <p:nvGrpSpPr>
-        <p:cNvPr id="1" name="">
-          <a:extLst>
-            <a:ext uri="{FF2B5EF4-FFF2-40B4-BE49-F238E27FC236}">
-              <a16:creationId xmlns:a16="http://schemas.microsoft.com/office/drawing/2014/main" id="{A5F8769B-96D5-FB86-647F-9E84199D00DD}"/>
-            </a:ext>
-          </a:extLst>
-        </p:cNvPr>
-        <p:cNvGrpSpPr/>
-        <p:nvPr/>
-      </p:nvGrpSpPr>
-      <p:grpSpPr>
-        <a:xfrm>
-          <a:off x="0" y="0"/>
-          <a:ext cx="0" cy="0"/>
-          <a:chOff x="0" y="0"/>
-          <a:chExt cx="0" cy="0"/>
-        </a:xfrm>
-      </p:grpSpPr>
-      <p:sp>
-        <p:nvSpPr>
-          <p:cNvPr id="3" name="內容版面配置區 2">
-            <a:extLst>
-              <a:ext uri="{FF2B5EF4-FFF2-40B4-BE49-F238E27FC236}">
-                <a16:creationId xmlns:a16="http://schemas.microsoft.com/office/drawing/2014/main" id="{6CAFB584-589A-4323-19D7-1DC80633D59A}"/>
-              </a:ext>
-            </a:extLst>
-          </p:cNvPr>
-          <p:cNvSpPr>
-            <a:spLocks noGrp="1"/>
-          </p:cNvSpPr>
-          <p:nvPr>
-            <p:ph idx="1"/>
-          </p:nvPr>
-        </p:nvSpPr>
-        <p:spPr/>
-        <p:txBody>
-          <a:bodyPr/>
-          <a:lstStyle/>
-          <a:p>
-            <a:pPr>
-              <a:spcBef>
-                <a:spcPts val="1200"/>
-              </a:spcBef>
-            </a:pPr>
-            <a:r>
-              <a:rPr lang="en-US" sz="2400" dirty="0">
-                <a:solidFill>
-                  <a:schemeClr val="bg2"/>
-                </a:solidFill>
-                <a:latin typeface="Times New Roman" panose="02020603050405020304" pitchFamily="18" charset="0"/>
-                <a:cs typeface="Times New Roman" panose="02020603050405020304" pitchFamily="18" charset="0"/>
-              </a:rPr>
-              <a:t>FPGA Selection and Spec</a:t>
-            </a:r>
-          </a:p>
-          <a:p>
-            <a:pPr>
-              <a:spcBef>
-                <a:spcPts val="1200"/>
-              </a:spcBef>
-            </a:pPr>
-            <a:r>
-              <a:rPr lang="en-US" sz="2400" dirty="0">
-                <a:solidFill>
-                  <a:schemeClr val="bg2"/>
-                </a:solidFill>
-                <a:latin typeface="Times New Roman" panose="02020603050405020304" pitchFamily="18" charset="0"/>
-                <a:cs typeface="Times New Roman" panose="02020603050405020304" pitchFamily="18" charset="0"/>
-              </a:rPr>
-              <a:t>Microcontroller Overview</a:t>
-            </a:r>
-          </a:p>
-          <a:p>
-            <a:pPr>
-              <a:spcBef>
-                <a:spcPts val="1200"/>
-              </a:spcBef>
-            </a:pPr>
-            <a:r>
-              <a:rPr lang="en-US" sz="2400" dirty="0">
-                <a:solidFill>
-                  <a:schemeClr val="bg2"/>
-                </a:solidFill>
-                <a:latin typeface="Times New Roman" panose="02020603050405020304" pitchFamily="18" charset="0"/>
-                <a:cs typeface="Times New Roman" panose="02020603050405020304" pitchFamily="18" charset="0"/>
-              </a:rPr>
-              <a:t>GPIO / Interrupt System / </a:t>
-            </a:r>
-            <a:r>
-              <a:rPr lang="zh-TW" altLang="en-US" sz="2400" dirty="0">
-                <a:solidFill>
-                  <a:schemeClr val="bg2"/>
-                </a:solidFill>
-                <a:latin typeface="Times New Roman" panose="02020603050405020304" pitchFamily="18" charset="0"/>
-                <a:cs typeface="Times New Roman" panose="02020603050405020304" pitchFamily="18" charset="0"/>
-              </a:rPr>
-              <a:t> </a:t>
-            </a:r>
-            <a:r>
-              <a:rPr lang="en-US" altLang="zh-TW" sz="2400" dirty="0">
-                <a:solidFill>
-                  <a:schemeClr val="bg2"/>
-                </a:solidFill>
-                <a:latin typeface="Times New Roman" panose="02020603050405020304" pitchFamily="18" charset="0"/>
-                <a:cs typeface="Times New Roman" panose="02020603050405020304" pitchFamily="18" charset="0"/>
-              </a:rPr>
-              <a:t>Timer &amp; PWM / XADC / UART</a:t>
-            </a:r>
-          </a:p>
-          <a:p>
-            <a:pPr>
-              <a:spcBef>
-                <a:spcPts val="1200"/>
-              </a:spcBef>
-            </a:pPr>
-            <a:r>
-              <a:rPr lang="en-US" altLang="zh-TW" sz="2400" dirty="0">
-                <a:solidFill>
-                  <a:schemeClr val="bg2"/>
-                </a:solidFill>
-                <a:latin typeface="Times New Roman" panose="02020603050405020304" pitchFamily="18" charset="0"/>
-                <a:cs typeface="Times New Roman" panose="02020603050405020304" pitchFamily="18" charset="0"/>
-              </a:rPr>
-              <a:t>Memory Hierarchy</a:t>
-            </a:r>
-          </a:p>
-          <a:p>
-            <a:pPr>
-              <a:spcBef>
-                <a:spcPts val="1200"/>
-              </a:spcBef>
-            </a:pPr>
-            <a:r>
-              <a:rPr lang="en-US" altLang="zh-TW" sz="2400" dirty="0">
-                <a:solidFill>
-                  <a:schemeClr val="bg2"/>
-                </a:solidFill>
-                <a:latin typeface="Times New Roman" panose="02020603050405020304" pitchFamily="18" charset="0"/>
-                <a:cs typeface="Times New Roman" panose="02020603050405020304" pitchFamily="18" charset="0"/>
-              </a:rPr>
-              <a:t>Hardware Report</a:t>
-            </a:r>
-            <a:endParaRPr lang="en-US" sz="2400" dirty="0">
-              <a:solidFill>
-                <a:schemeClr val="bg2"/>
-              </a:solidFill>
-              <a:latin typeface="Times New Roman" panose="02020603050405020304" pitchFamily="18" charset="0"/>
-              <a:cs typeface="Times New Roman" panose="02020603050405020304" pitchFamily="18" charset="0"/>
-            </a:endParaRPr>
-          </a:p>
-          <a:p>
-            <a:pPr>
-              <a:spcBef>
-                <a:spcPts val="1200"/>
-              </a:spcBef>
-            </a:pPr>
-            <a:r>
-              <a:rPr lang="en-US" sz="2400" dirty="0">
-                <a:solidFill>
-                  <a:schemeClr val="bg2"/>
-                </a:solidFill>
-                <a:latin typeface="Times New Roman" panose="02020603050405020304" pitchFamily="18" charset="0"/>
-                <a:cs typeface="Times New Roman" panose="02020603050405020304" pitchFamily="18" charset="0"/>
-              </a:rPr>
-              <a:t>Software Design Flow</a:t>
-            </a:r>
-          </a:p>
-          <a:p>
-            <a:pPr>
-              <a:spcBef>
-                <a:spcPts val="1200"/>
-              </a:spcBef>
-            </a:pPr>
-            <a:r>
-              <a:rPr lang="en-US" sz="2400" dirty="0">
-                <a:latin typeface="Times New Roman" panose="02020603050405020304" pitchFamily="18" charset="0"/>
-                <a:cs typeface="Times New Roman" panose="02020603050405020304" pitchFamily="18" charset="0"/>
-              </a:rPr>
-              <a:t>JTAG Debug Flow</a:t>
-            </a:r>
-          </a:p>
-          <a:p>
-            <a:pPr>
-              <a:spcBef>
-                <a:spcPts val="1200"/>
-              </a:spcBef>
-            </a:pPr>
-            <a:r>
-              <a:rPr lang="en-US" sz="2400" dirty="0">
-                <a:solidFill>
-                  <a:schemeClr val="bg2"/>
-                </a:solidFill>
-                <a:latin typeface="Times New Roman" panose="02020603050405020304" pitchFamily="18" charset="0"/>
-                <a:cs typeface="Times New Roman" panose="02020603050405020304" pitchFamily="18" charset="0"/>
-              </a:rPr>
-              <a:t>Standalone Boot Sequence</a:t>
-            </a:r>
-          </a:p>
-        </p:txBody>
-      </p:sp>
-      <p:sp>
-        <p:nvSpPr>
-          <p:cNvPr id="4" name="投影片編號版面配置區 3">
-            <a:extLst>
-              <a:ext uri="{FF2B5EF4-FFF2-40B4-BE49-F238E27FC236}">
-                <a16:creationId xmlns:a16="http://schemas.microsoft.com/office/drawing/2014/main" id="{DD7D01D4-C40B-FE2A-564A-D957653CEF40}"/>
-              </a:ext>
-            </a:extLst>
-          </p:cNvPr>
-          <p:cNvSpPr>
-            <a:spLocks noGrp="1"/>
-          </p:cNvSpPr>
-          <p:nvPr>
-            <p:ph type="sldNum" sz="quarter" idx="12"/>
-          </p:nvPr>
-        </p:nvSpPr>
-        <p:spPr/>
-        <p:txBody>
-          <a:bodyPr/>
-          <a:lstStyle/>
-          <a:p>
-            <a:fld id="{F9F9ED32-46C6-469E-9D81-E8934DBD0961}" type="slidenum">
-              <a:rPr lang="zh-TW" altLang="en-US" smtClean="0"/>
-              <a:t>29</a:t>
-            </a:fld>
-            <a:endParaRPr lang="zh-TW" altLang="en-US" dirty="0"/>
-          </a:p>
-        </p:txBody>
-      </p:sp>
-    </p:spTree>
-    <p:extLst>
-      <p:ext uri="{BB962C8B-B14F-4D97-AF65-F5344CB8AC3E}">
-        <p14:creationId xmlns:p14="http://schemas.microsoft.com/office/powerpoint/2010/main" val="1347852348"/>
-      </p:ext>
-    </p:extLst>
-  </p:cSld>
-  <p:clrMapOvr>
-    <a:masterClrMapping/>
-  </p:clrMapOvr>
-  <mc:AlternateContent xmlns:mc="http://schemas.openxmlformats.org/markup-compatibility/2006" xmlns:p14="http://schemas.microsoft.com/office/powerpoint/2010/main">
-    <mc:Choice Requires="p14">
-      <p:transition spd="slow" p14:dur="2000">
-        <p:cut/>
-      </p:transition>
-    </mc:Choice>
-    <mc:Fallback xmlns="">
-      <p:transition spd="slow">
-        <p:cut/>
-      </p:transition>
-    </mc:Fallback>
-  </mc:AlternateContent>
 </p:sld>
 </file>
 
@@ -15486,7 +15433,7 @@
                 <a:latin typeface="Times New Roman" panose="02020603050405020304" pitchFamily="18" charset="0"/>
                 <a:cs typeface="Times New Roman" panose="02020603050405020304" pitchFamily="18" charset="0"/>
               </a:rPr>
-              <a:t>GPIO / Interrupt System / </a:t>
+              <a:t>MDM / GPIO / Interrupt System / </a:t>
             </a:r>
             <a:r>
               <a:rPr lang="zh-TW" altLang="en-US" sz="2400" dirty="0">
@@ -15662,6 +15609,265 @@
   <p:cSld>
     <p:spTree>
       <p:nvGrpSpPr>
+        <p:cNvPr id="1" name="">
+          <a:extLst>
+            <a:ext uri="{FF2B5EF4-FFF2-40B4-BE49-F238E27FC236}">
+              <a16:creationId xmlns:a16="http://schemas.microsoft.com/office/drawing/2014/main" id="{A5F8769B-96D5-FB86-647F-9E84199D00DD}"/>
+            </a:ext>
+          </a:extLst>
+        </p:cNvPr>
+        <p:cNvGrpSpPr/>
+        <p:nvPr/>
+      </p:nvGrpSpPr>
+      <p:grpSpPr>
+        <a:xfrm>
+          <a:off x="0" y="0"/>
+          <a:ext cx="0" cy="0"/>
+          <a:chOff x="0" y="0"/>
+          <a:chExt cx="0" cy="0"/>
+        </a:xfrm>
+      </p:grpSpPr>
+      <p:sp>
+        <p:nvSpPr>
+          <p:cNvPr id="3" name="內容版面配置區 2">
+            <a:extLst>
+              <a:ext uri="{FF2B5EF4-FFF2-40B4-BE49-F238E27FC236}">
+                <a16:creationId xmlns:a16="http://schemas.microsoft.com/office/drawing/2014/main" id="{6CAFB584-589A-4323-19D7-1DC80633D59A}"/>
+              </a:ext>
+            </a:extLst>
+          </p:cNvPr>
+          <p:cNvSpPr>
+            <a:spLocks noGrp="1"/>
+          </p:cNvSpPr>
+          <p:nvPr>
+            <p:ph idx="1"/>
+          </p:nvPr>
+        </p:nvSpPr>
+        <p:spPr/>
+        <p:txBody>
+          <a:bodyPr/>
+          <a:lstStyle/>
+          <a:p>
+            <a:pPr>
+              <a:spcBef>
+                <a:spcPts val="1200"/>
+              </a:spcBef>
+            </a:pPr>
+            <a:r>
+              <a:rPr lang="en-US" sz="2400" dirty="0">
+                <a:solidFill>
+                  <a:schemeClr val="bg2"/>
+                </a:solidFill>
+                <a:latin typeface="Times New Roman" panose="02020603050405020304" pitchFamily="18" charset="0"/>
+                <a:cs typeface="Times New Roman" panose="02020603050405020304" pitchFamily="18" charset="0"/>
+              </a:rPr>
+              <a:t>FPGA Selection and Spec</a:t>
+            </a:r>
+          </a:p>
+          <a:p>
+            <a:pPr>
+              <a:spcBef>
+                <a:spcPts val="1200"/>
+              </a:spcBef>
+            </a:pPr>
+            <a:r>
+              <a:rPr lang="en-US" sz="2400" dirty="0">
+                <a:solidFill>
+                  <a:schemeClr val="bg2"/>
+                </a:solidFill>
+                <a:latin typeface="Times New Roman" panose="02020603050405020304" pitchFamily="18" charset="0"/>
+                <a:cs typeface="Times New Roman" panose="02020603050405020304" pitchFamily="18" charset="0"/>
+              </a:rPr>
+              <a:t>Microcontroller Overview</a:t>
+            </a:r>
+          </a:p>
+          <a:p>
+            <a:pPr>
+              <a:spcBef>
+                <a:spcPts val="1200"/>
+              </a:spcBef>
+            </a:pPr>
+            <a:r>
+              <a:rPr lang="en-US" sz="2400" dirty="0">
+                <a:solidFill>
+                  <a:schemeClr val="bg2"/>
+                </a:solidFill>
+                <a:latin typeface="Times New Roman" panose="02020603050405020304" pitchFamily="18" charset="0"/>
+                <a:cs typeface="Times New Roman" panose="02020603050405020304" pitchFamily="18" charset="0"/>
+              </a:rPr>
+              <a:t>MDM / GPIO / Interrupt System / </a:t>
+            </a:r>
+            <a:r>
+              <a:rPr lang="zh-TW" altLang="en-US" sz="2400" dirty="0">
+                <a:solidFill>
+                  <a:schemeClr val="bg2"/>
+                </a:solidFill>
+                <a:latin typeface="Times New Roman" panose="02020603050405020304" pitchFamily="18" charset="0"/>
+                <a:cs typeface="Times New Roman" panose="02020603050405020304" pitchFamily="18" charset="0"/>
+              </a:rPr>
+              <a:t> </a:t>
+            </a:r>
+            <a:r>
+              <a:rPr lang="en-US" altLang="zh-TW" sz="2400" dirty="0">
+                <a:solidFill>
+                  <a:schemeClr val="bg2"/>
+                </a:solidFill>
+                <a:latin typeface="Times New Roman" panose="02020603050405020304" pitchFamily="18" charset="0"/>
+                <a:cs typeface="Times New Roman" panose="02020603050405020304" pitchFamily="18" charset="0"/>
+              </a:rPr>
+              <a:t>Timer &amp; PWM / XADC / UART</a:t>
+            </a:r>
+          </a:p>
+          <a:p>
+            <a:pPr>
+              <a:spcBef>
+                <a:spcPts val="1200"/>
+              </a:spcBef>
+            </a:pPr>
+            <a:r>
+              <a:rPr lang="en-US" altLang="zh-TW" sz="2400" dirty="0">
+                <a:solidFill>
+                  <a:schemeClr val="bg2"/>
+                </a:solidFill>
+                <a:latin typeface="Times New Roman" panose="02020603050405020304" pitchFamily="18" charset="0"/>
+                <a:cs typeface="Times New Roman" panose="02020603050405020304" pitchFamily="18" charset="0"/>
+              </a:rPr>
+              <a:t>Memory Hierarchy</a:t>
+            </a:r>
+          </a:p>
+          <a:p>
+            <a:pPr>
+              <a:spcBef>
+                <a:spcPts val="1200"/>
+              </a:spcBef>
+            </a:pPr>
+            <a:r>
+              <a:rPr lang="en-US" altLang="zh-TW" sz="2400" dirty="0">
+                <a:solidFill>
+                  <a:schemeClr val="bg2"/>
+                </a:solidFill>
+                <a:latin typeface="Times New Roman" panose="02020603050405020304" pitchFamily="18" charset="0"/>
+                <a:cs typeface="Times New Roman" panose="02020603050405020304" pitchFamily="18" charset="0"/>
+              </a:rPr>
+              <a:t>Hardware Report</a:t>
+            </a:r>
+            <a:endParaRPr lang="en-US" sz="2400" dirty="0">
+              <a:solidFill>
+                <a:schemeClr val="bg2"/>
+              </a:solidFill>
+              <a:latin typeface="Times New Roman" panose="02020603050405020304" pitchFamily="18" charset="0"/>
+              <a:cs typeface="Times New Roman" panose="02020603050405020304" pitchFamily="18" charset="0"/>
+            </a:endParaRPr>
+          </a:p>
+          <a:p>
+            <a:pPr>
+              <a:spcBef>
+                <a:spcPts val="1200"/>
+              </a:spcBef>
+            </a:pPr>
+            <a:r>
+              <a:rPr lang="en-US" sz="2400" dirty="0">
+                <a:solidFill>
+                  <a:schemeClr val="bg2"/>
+                </a:solidFill>
+                <a:latin typeface="Times New Roman" panose="02020603050405020304" pitchFamily="18" charset="0"/>
+                <a:cs typeface="Times New Roman" panose="02020603050405020304" pitchFamily="18" charset="0"/>
+              </a:rPr>
+              <a:t>Software Design Flow</a:t>
+            </a:r>
+          </a:p>
+          <a:p>
+            <a:pPr>
+              <a:spcBef>
+                <a:spcPts val="1200"/>
+              </a:spcBef>
+            </a:pPr>
+            <a:r>
+              <a:rPr lang="en-US" sz="2400" dirty="0">
+                <a:latin typeface="Times New Roman" panose="02020603050405020304" pitchFamily="18" charset="0"/>
+                <a:cs typeface="Times New Roman" panose="02020603050405020304" pitchFamily="18" charset="0"/>
+              </a:rPr>
+              <a:t>JTAG Debug Flow</a:t>
+            </a:r>
+          </a:p>
+          <a:p>
+            <a:pPr>
+              <a:spcBef>
+                <a:spcPts val="1200"/>
+              </a:spcBef>
+            </a:pPr>
+            <a:r>
+              <a:rPr lang="en-US" sz="2400" dirty="0">
+                <a:solidFill>
+                  <a:schemeClr val="bg2"/>
+                </a:solidFill>
+                <a:latin typeface="Times New Roman" panose="02020603050405020304" pitchFamily="18" charset="0"/>
+                <a:cs typeface="Times New Roman" panose="02020603050405020304" pitchFamily="18" charset="0"/>
+              </a:rPr>
+              <a:t>Standalone Boot Sequence</a:t>
+            </a:r>
+          </a:p>
+        </p:txBody>
+      </p:sp>
+      <p:sp>
+        <p:nvSpPr>
+          <p:cNvPr id="4" name="投影片編號版面配置區 3">
+            <a:extLst>
+              <a:ext uri="{FF2B5EF4-FFF2-40B4-BE49-F238E27FC236}">
+                <a16:creationId xmlns:a16="http://schemas.microsoft.com/office/drawing/2014/main" id="{DD7D01D4-C40B-FE2A-564A-D957653CEF40}"/>
+              </a:ext>
+            </a:extLst>
+          </p:cNvPr>
+          <p:cNvSpPr>
+            <a:spLocks noGrp="1"/>
+          </p:cNvSpPr>
+          <p:nvPr>
+            <p:ph type="sldNum" sz="quarter" idx="12"/>
+          </p:nvPr>
+        </p:nvSpPr>
+        <p:spPr/>
+        <p:txBody>
+          <a:bodyPr/>
+          <a:lstStyle/>
+          <a:p>
+            <a:fld id="{F9F9ED32-46C6-469E-9D81-E8934DBD0961}" type="slidenum">
+              <a:rPr lang="zh-TW" altLang="en-US" smtClean="0"/>
+              <a:t>30</a:t>
+            </a:fld>
+            <a:endParaRPr lang="zh-TW" altLang="en-US" dirty="0"/>
+          </a:p>
+        </p:txBody>
+      </p:sp>
+    </p:spTree>
+    <p:extLst>
+      <p:ext uri="{BB962C8B-B14F-4D97-AF65-F5344CB8AC3E}">
+        <p14:creationId xmlns:p14="http://schemas.microsoft.com/office/powerpoint/2010/main" val="1347852348"/>
+      </p:ext>
+    </p:extLst>
+  </p:cSld>
+  <p:clrMapOvr>
+    <a:masterClrMapping/>
+  </p:clrMapOvr>
+  <mc:AlternateContent xmlns:mc="http://schemas.openxmlformats.org/markup-compatibility/2006" xmlns:p14="http://schemas.microsoft.com/office/powerpoint/2010/main">
+    <mc:Choice Requires="p14">
+      <p:transition spd="slow" p14:dur="2000">
+        <p:cut/>
+      </p:transition>
+    </mc:Choice>
+    <mc:Fallback xmlns="">
+      <p:transition spd="slow">
+        <p:cut/>
+      </p:transition>
+    </mc:Fallback>
+  </mc:AlternateContent>
+</p:sld>
+</file>
+
+<file path=ppt/slides/slide31.xml><?xml version="1.0" encoding="utf-8"?>
+<p:sld xmlns:a="http://schemas.openxmlformats.org/drawingml/2006/main" xmlns:r="http://schemas.openxmlformats.org/officeDocument/2006/relationships" xmlns:p="http://schemas.openxmlformats.org/presentationml/2006/main">
+  <p:cSld>
+    <p:spTree>
+      <p:nvGrpSpPr>
         <p:cNvPr id="1" name=""/>
         <p:cNvGrpSpPr/>
         <p:nvPr/>
@@ -15726,7 +15932,7 @@
             <a:fld id="{F9F9ED32-46C6-469E-9D81-E8934DBD0961}" type="slidenum">
               <a:rPr lang="zh-TW" altLang="en-US" smtClean="0"/>
               <a:pPr/>
-              <a:t>30</a:t>
+              <a:t>31</a:t>
             </a:fld>
             <a:endParaRPr lang="zh-TW" altLang="en-US" dirty="0"/>
           </a:p>
@@ -15787,7 +15993,7 @@
 </p:sld>
 </file>
 
-<file path=ppt/slides/slide31.xml><?xml version="1.0" encoding="utf-8"?>
+<file path=ppt/slides/slide32.xml><?xml version="1.0" encoding="utf-8"?>
 <p:sld xmlns:a="http://schemas.openxmlformats.org/drawingml/2006/main" xmlns:r="http://schemas.openxmlformats.org/officeDocument/2006/relationships" xmlns:p="http://schemas.openxmlformats.org/presentationml/2006/main">
   <p:cSld>
     <p:spTree>
@@ -15878,7 +16084,7 @@
                 <a:latin typeface="Times New Roman" panose="02020603050405020304" pitchFamily="18" charset="0"/>
                 <a:cs typeface="Times New Roman" panose="02020603050405020304" pitchFamily="18" charset="0"/>
               </a:rPr>
-              <a:t>GPIO / Interrupt System / </a:t>
+              <a:t>MDM / GPIO / Interrupt System / </a:t>
             </a:r>
             <a:r>
               <a:rPr lang="zh-TW" altLang="en-US" sz="2400" dirty="0">
@@ -16015,7 +16221,7 @@
           <a:p>
             <a:fld id="{F9F9ED32-46C6-469E-9D81-E8934DBD0961}" type="slidenum">
               <a:rPr lang="zh-TW" altLang="en-US" smtClean="0"/>
-              <a:t>31</a:t>
+              <a:t>32</a:t>
             </a:fld>
             <a:endParaRPr lang="zh-TW" altLang="en-US" dirty="0"/>
           </a:p>
@@ -16046,7 +16252,7 @@
 </p:sld>
 </file>
 
-<file path=ppt/slides/slide32.xml><?xml version="1.0" encoding="utf-8"?>
+<file path=ppt/slides/slide33.xml><?xml version="1.0" encoding="utf-8"?>
 <p:sld xmlns:a="http://schemas.openxmlformats.org/drawingml/2006/main" xmlns:r="http://schemas.openxmlformats.org/officeDocument/2006/relationships" xmlns:p="http://schemas.openxmlformats.org/presentationml/2006/main">
   <p:cSld>
     <p:spTree>
@@ -16240,7 +16446,7 @@
           <a:p>
             <a:fld id="{5E7A655E-BA10-45EB-B439-1EA08694B58E}" type="slidenum">
               <a:rPr lang="en-TW" smtClean="0"/>
-              <a:t>32</a:t>
+              <a:t>33</a:t>
             </a:fld>
             <a:endParaRPr lang="en-TW"/>
           </a:p>
@@ -16254,7 +16460,197 @@
 </p:sld>
 </file>
 
-<file path=ppt/slides/slide33.xml><?xml version="1.0" encoding="utf-8"?>
+<file path=ppt/slides/slide34.xml><?xml version="1.0" encoding="utf-8"?>
+<p:sld xmlns:a="http://schemas.openxmlformats.org/drawingml/2006/main" xmlns:r="http://schemas.openxmlformats.org/officeDocument/2006/relationships" xmlns:p="http://schemas.openxmlformats.org/presentationml/2006/main">
+  <p:cSld>
+    <p:spTree>
+      <p:nvGrpSpPr>
+        <p:cNvPr id="1" name="">
+          <a:extLst>
+            <a:ext uri="{FF2B5EF4-FFF2-40B4-BE49-F238E27FC236}">
+              <a16:creationId xmlns:a16="http://schemas.microsoft.com/office/drawing/2014/main" id="{9DA7893A-8BF1-8DC8-2B43-CEC364136D45}"/>
+            </a:ext>
+          </a:extLst>
+        </p:cNvPr>
+        <p:cNvGrpSpPr/>
+        <p:nvPr/>
+      </p:nvGrpSpPr>
+      <p:grpSpPr>
+        <a:xfrm>
+          <a:off x="0" y="0"/>
+          <a:ext cx="0" cy="0"/>
+          <a:chOff x="0" y="0"/>
+          <a:chExt cx="0" cy="0"/>
+        </a:xfrm>
+      </p:grpSpPr>
+      <p:sp>
+        <p:nvSpPr>
+          <p:cNvPr id="2" name="標題 1">
+            <a:extLst>
+              <a:ext uri="{FF2B5EF4-FFF2-40B4-BE49-F238E27FC236}">
+                <a16:creationId xmlns:a16="http://schemas.microsoft.com/office/drawing/2014/main" id="{F8231ED6-7A51-971B-6D84-5CBC6DAFE4F2}"/>
+              </a:ext>
+            </a:extLst>
+          </p:cNvPr>
+          <p:cNvSpPr>
+            <a:spLocks noGrp="1"/>
+          </p:cNvSpPr>
+          <p:nvPr>
+            <p:ph type="title"/>
+          </p:nvPr>
+        </p:nvSpPr>
+        <p:spPr>
+          <a:xfrm>
+            <a:off x="900000" y="108000"/>
+            <a:ext cx="10972800" cy="707886"/>
+          </a:xfrm>
+        </p:spPr>
+        <p:txBody>
+          <a:bodyPr/>
+          <a:lstStyle/>
+          <a:p>
+            <a:r>
+              <a:rPr lang="en-US" altLang="zh-TW" dirty="0"/>
+              <a:t>Reference</a:t>
+            </a:r>
+            <a:endParaRPr lang="en-US" dirty="0"/>
+          </a:p>
+        </p:txBody>
+      </p:sp>
+      <p:sp>
+        <p:nvSpPr>
+          <p:cNvPr id="3" name="內容版面配置區 2">
+            <a:extLst>
+              <a:ext uri="{FF2B5EF4-FFF2-40B4-BE49-F238E27FC236}">
+                <a16:creationId xmlns:a16="http://schemas.microsoft.com/office/drawing/2014/main" id="{72F73930-F4A3-EFC6-5CCF-C23BB7EDEA1C}"/>
+              </a:ext>
+            </a:extLst>
+          </p:cNvPr>
+          <p:cNvSpPr>
+            <a:spLocks noGrp="1"/>
+          </p:cNvSpPr>
+          <p:nvPr>
+            <p:ph idx="1"/>
+          </p:nvPr>
+        </p:nvSpPr>
+        <p:spPr>
+          <a:xfrm>
+            <a:off x="334965" y="1482725"/>
+            <a:ext cx="11254061" cy="5113338"/>
+          </a:xfrm>
+        </p:spPr>
+        <p:txBody>
+          <a:bodyPr/>
+          <a:lstStyle/>
+          <a:p>
+            <a:r>
+              <a:rPr lang="en-US" sz="2000" dirty="0">
+                <a:hlinkClick r:id="rId2"/>
+              </a:rPr>
+              <a:t>The RISC-V Instruction Set Manual, Volume I :: RISC-V Ratified Specifications Library</a:t>
+            </a:r>
+            <a:endParaRPr lang="en-US" sz="2000" dirty="0"/>
+          </a:p>
+          <a:p>
+            <a:r>
+              <a:rPr lang="en-US" sz="2000" dirty="0">
+                <a:hlinkClick r:id="rId3"/>
+              </a:rPr>
+              <a:t>The RISC-V Instruction Set Manual, Volume II :: RISC-V Ratified Specifications Library</a:t>
+            </a:r>
+            <a:endParaRPr lang="en-US" sz="2000" dirty="0"/>
+          </a:p>
+          <a:p>
+            <a:r>
+              <a:rPr lang="en-US" sz="2000" dirty="0">
+                <a:hlinkClick r:id="rId4"/>
+              </a:rPr>
+              <a:t>riscv-debug-release.pdf</a:t>
+            </a:r>
+            <a:endParaRPr lang="en-US" sz="2000" dirty="0"/>
+          </a:p>
+          <a:p>
+            <a:r>
+              <a:rPr lang="en-US" sz="2000" dirty="0">
+                <a:hlinkClick r:id="rId5"/>
+              </a:rPr>
+              <a:t>Introduction • MicroBlaze V Processor Reference Guide (UG1629) • Reader • AMD Technical Information Portal</a:t>
+            </a:r>
+            <a:endParaRPr lang="en-US" sz="2000" dirty="0"/>
+          </a:p>
+          <a:p>
+            <a:r>
+              <a:rPr lang="en-US" sz="2000" dirty="0">
+                <a:hlinkClick r:id="rId6"/>
+              </a:rPr>
+              <a:t>Introduction • MicroBlaze Debug Module V (MDM V) LogiCORE IP Product Guide (PG428) • Reader • AMD Technical Information Portal</a:t>
+            </a:r>
+            <a:endParaRPr lang="en-US" sz="2000" dirty="0"/>
+          </a:p>
+          <a:p>
+            <a:r>
+              <a:rPr lang="en-US" sz="2000" dirty="0">
+                <a:hlinkClick r:id="rId7"/>
+              </a:rPr>
+              <a:t>Getting Started with Vitis • Vitis Unified Software Platform Documentation: Embedded Software Development (UG1400) • Reader • AMD Technical Information Portal</a:t>
+            </a:r>
+            <a:endParaRPr lang="en-US" sz="2000" dirty="0"/>
+          </a:p>
+          <a:p>
+            <a:r>
+              <a:rPr lang="en-US" sz="2000" dirty="0">
+                <a:hlinkClick r:id="rId8"/>
+              </a:rPr>
+              <a:t>BSP and Libraries Overview • Standalone Library Documentation: BSP and Libraries Document Collection (UG643) • Reader • AMD Technical Information Portal</a:t>
+            </a:r>
+            <a:endParaRPr lang="en-US" sz="2000" dirty="0"/>
+          </a:p>
+        </p:txBody>
+      </p:sp>
+      <p:sp>
+        <p:nvSpPr>
+          <p:cNvPr id="4" name="投影片編號版面配置區 3">
+            <a:extLst>
+              <a:ext uri="{FF2B5EF4-FFF2-40B4-BE49-F238E27FC236}">
+                <a16:creationId xmlns:a16="http://schemas.microsoft.com/office/drawing/2014/main" id="{7825DA5F-4290-B259-5B5A-700398A00821}"/>
+              </a:ext>
+            </a:extLst>
+          </p:cNvPr>
+          <p:cNvSpPr>
+            <a:spLocks noGrp="1"/>
+          </p:cNvSpPr>
+          <p:nvPr>
+            <p:ph type="sldNum" sz="quarter" idx="12"/>
+          </p:nvPr>
+        </p:nvSpPr>
+        <p:spPr/>
+        <p:txBody>
+          <a:bodyPr/>
+          <a:lstStyle/>
+          <a:p>
+            <a:fld id="{F9F9ED32-46C6-469E-9D81-E8934DBD0961}" type="slidenum">
+              <a:rPr lang="zh-TW" altLang="en-US" smtClean="0"/>
+              <a:pPr/>
+              <a:t>34</a:t>
+            </a:fld>
+            <a:endParaRPr lang="zh-TW" altLang="en-US" dirty="0"/>
+          </a:p>
+        </p:txBody>
+      </p:sp>
+    </p:spTree>
+    <p:extLst>
+      <p:ext uri="{BB962C8B-B14F-4D97-AF65-F5344CB8AC3E}">
+        <p14:creationId xmlns:p14="http://schemas.microsoft.com/office/powerpoint/2010/main" val="3167141079"/>
+      </p:ext>
+    </p:extLst>
+  </p:cSld>
+  <p:clrMapOvr>
+    <a:masterClrMapping/>
+  </p:clrMapOvr>
+</p:sld>
+</file>
+
+<file path=ppt/slides/slide35.xml><?xml version="1.0" encoding="utf-8"?>
 <p:sld xmlns:a="http://schemas.openxmlformats.org/drawingml/2006/main" xmlns:r="http://schemas.openxmlformats.org/officeDocument/2006/relationships" xmlns:p="http://schemas.openxmlformats.org/presentationml/2006/main">
   <p:cSld>
     <p:spTree>
@@ -16448,7 +16844,7 @@
           <a:p>
             <a:fld id="{F9F9ED32-46C6-469E-9D81-E8934DBD0961}" type="slidenum">
               <a:rPr lang="zh-TW" altLang="en-US" smtClean="0"/>
-              <a:t>33</a:t>
+              <a:t>35</a:t>
             </a:fld>
             <a:endParaRPr lang="zh-TW" altLang="en-US" dirty="0"/>
           </a:p>
@@ -19462,7 +19858,7 @@
                 <a:latin typeface="Times New Roman" panose="02020603050405020304" pitchFamily="18" charset="0"/>
                 <a:cs typeface="Times New Roman" panose="02020603050405020304" pitchFamily="18" charset="0"/>
               </a:rPr>
-              <a:t>GPIO / Interrupt System / </a:t>
+              <a:t>MDM / GPIO / Interrupt System / </a:t>
             </a:r>
             <a:r>
               <a:rPr lang="zh-TW" altLang="en-US" sz="2400" dirty="0">
@@ -19753,7 +20149,7 @@
               </a:lnSpc>
             </a:pPr>
             <a:r>
-              <a:rPr lang="en-US" sz="1400" b="0" strike="noStrike" spc="-1">
+              <a:rPr lang="en-US" sz="1400" b="0" strike="noStrike" spc="-1" dirty="0">
                 <a:solidFill>
                   <a:schemeClr val="dk1"/>
                 </a:solidFill>
@@ -19761,7 +20157,7 @@
               </a:rPr>
               <a:t>MicroBlaze V</a:t>
             </a:r>
-            <a:endParaRPr lang="en-US" sz="1400" b="0" strike="noStrike" spc="-1">
+            <a:endParaRPr lang="en-US" sz="1400" b="0" strike="noStrike" spc="-1" dirty="0">
               <a:solidFill>
                 <a:srgbClr val="000000"/>
               </a:solidFill>
@@ -22581,7 +22977,7 @@
               </a:lnSpc>
             </a:pPr>
             <a:r>
-              <a:rPr lang="en-US" sz="1400" b="0" strike="noStrike" spc="-1">
+              <a:rPr lang="en-US" sz="1400" b="0" strike="noStrike" spc="-1" dirty="0">
                 <a:solidFill>
                   <a:schemeClr val="dk1"/>
                 </a:solidFill>
@@ -22589,7 +22985,7 @@
               </a:rPr>
               <a:t>MicroBlaze V</a:t>
             </a:r>
-            <a:endParaRPr lang="en-US" sz="1400" b="0" strike="noStrike" spc="-1">
+            <a:endParaRPr lang="en-US" sz="1400" b="0" strike="noStrike" spc="-1" dirty="0">
               <a:solidFill>
                 <a:srgbClr val="000000"/>
               </a:solidFill>

</xml_diff>